<commit_message>
Update oddiy1: new template structure, text-only, no images, uppercase titles
</commit_message>
<xml_diff>
--- a/templates/shablonlar/oddiy1.pptx
+++ b/templates/shablonlar/oddiy1.pptx
@@ -11,7 +11,7 @@
     <p:sldId id="256" r:id="rId2"/>
     <p:sldId id="257" r:id="rId3"/>
     <p:sldId id="258" r:id="rId4"/>
-    <p:sldId id="259" r:id="rId5"/>
+    <p:sldId id="264" r:id="rId5"/>
     <p:sldId id="260" r:id="rId6"/>
     <p:sldId id="261" r:id="rId7"/>
     <p:sldId id="263" r:id="rId8"/>
@@ -1041,110 +1041,6 @@
   <p:cSld>
     <p:spTree>
       <p:nvGrpSpPr>
-        <p:cNvPr id="1" name="Shape 110"/>
-        <p:cNvGrpSpPr/>
-        <p:nvPr/>
-      </p:nvGrpSpPr>
-      <p:grpSpPr>
-        <a:xfrm>
-          <a:off x="0" y="0"/>
-          <a:ext cx="0" cy="0"/>
-          <a:chOff x="0" y="0"/>
-          <a:chExt cx="0" cy="0"/>
-        </a:xfrm>
-      </p:grpSpPr>
-      <p:sp>
-        <p:nvSpPr>
-          <p:cNvPr id="111" name="Google Shape;111;p4:notes"/>
-          <p:cNvSpPr txBox="1">
-            <a:spLocks noGrp="1"/>
-          </p:cNvSpPr>
-          <p:nvPr>
-            <p:ph type="body" idx="1"/>
-          </p:nvPr>
-        </p:nvSpPr>
-        <p:spPr>
-          <a:xfrm>
-            <a:off x="685800" y="4343400"/>
-            <a:ext cx="5486400" cy="4114800"/>
-          </a:xfrm>
-          <a:prstGeom prst="rect">
-            <a:avLst/>
-          </a:prstGeom>
-        </p:spPr>
-        <p:txBody>
-          <a:bodyPr spcFirstLastPara="1" wrap="square" lIns="91425" tIns="91425" rIns="91425" bIns="91425" anchor="t" anchorCtr="0">
-            <a:noAutofit/>
-          </a:bodyPr>
-          <a:lstStyle/>
-          <a:p>
-            <a:pPr marL="0" lvl="0" indent="0" algn="l" rtl="0">
-              <a:spcBef>
-                <a:spcPts val="0"/>
-              </a:spcBef>
-              <a:spcAft>
-                <a:spcPts val="0"/>
-              </a:spcAft>
-              <a:buNone/>
-            </a:pPr>
-            <a:endParaRPr/>
-          </a:p>
-        </p:txBody>
-      </p:sp>
-      <p:sp>
-        <p:nvSpPr>
-          <p:cNvPr id="112" name="Google Shape;112;p4:notes"/>
-          <p:cNvSpPr>
-            <a:spLocks noGrp="1" noRot="1" noChangeAspect="1"/>
-          </p:cNvSpPr>
-          <p:nvPr>
-            <p:ph type="sldImg" idx="2"/>
-          </p:nvPr>
-        </p:nvSpPr>
-        <p:spPr>
-          <a:xfrm>
-            <a:off x="381000" y="685800"/>
-            <a:ext cx="6096000" cy="3429000"/>
-          </a:xfrm>
-          <a:custGeom>
-            <a:avLst/>
-            <a:gdLst/>
-            <a:ahLst/>
-            <a:cxnLst/>
-            <a:rect l="l" t="t" r="r" b="b"/>
-            <a:pathLst>
-              <a:path w="120000" h="120000" extrusionOk="0">
-                <a:moveTo>
-                  <a:pt x="0" y="0"/>
-                </a:moveTo>
-                <a:lnTo>
-                  <a:pt x="120000" y="0"/>
-                </a:lnTo>
-                <a:lnTo>
-                  <a:pt x="120000" y="120000"/>
-                </a:lnTo>
-                <a:lnTo>
-                  <a:pt x="0" y="120000"/>
-                </a:lnTo>
-                <a:close/>
-              </a:path>
-            </a:pathLst>
-          </a:custGeom>
-        </p:spPr>
-      </p:sp>
-    </p:spTree>
-  </p:cSld>
-  <p:clrMapOvr>
-    <a:masterClrMapping/>
-  </p:clrMapOvr>
-</p:notes>
-</file>
-
-<file path=ppt/notesSlides/notesSlide5.xml><?xml version="1.0" encoding="utf-8"?>
-<p:notes xmlns:a="http://schemas.openxmlformats.org/drawingml/2006/main" xmlns:r="http://schemas.openxmlformats.org/officeDocument/2006/relationships" xmlns:p="http://schemas.openxmlformats.org/presentationml/2006/main" showMasterSp="0" showMasterPhAnim="0">
-  <p:cSld>
-    <p:spTree>
-      <p:nvGrpSpPr>
         <p:cNvPr id="1" name="Shape 122"/>
         <p:cNvGrpSpPr/>
         <p:nvPr/>
@@ -1244,7 +1140,7 @@
 </p:notes>
 </file>
 
-<file path=ppt/notesSlides/notesSlide6.xml><?xml version="1.0" encoding="utf-8"?>
+<file path=ppt/notesSlides/notesSlide5.xml><?xml version="1.0" encoding="utf-8"?>
 <p:notes xmlns:a="http://schemas.openxmlformats.org/drawingml/2006/main" xmlns:r="http://schemas.openxmlformats.org/officeDocument/2006/relationships" xmlns:p="http://schemas.openxmlformats.org/presentationml/2006/main" showMasterSp="0" showMasterPhAnim="0">
   <p:cSld>
     <p:spTree>
@@ -1348,7 +1244,7 @@
 </p:notes>
 </file>
 
-<file path=ppt/notesSlides/notesSlide7.xml><?xml version="1.0" encoding="utf-8"?>
+<file path=ppt/notesSlides/notesSlide6.xml><?xml version="1.0" encoding="utf-8"?>
 <p:notes xmlns:a="http://schemas.openxmlformats.org/drawingml/2006/main" xmlns:r="http://schemas.openxmlformats.org/officeDocument/2006/relationships" xmlns:p="http://schemas.openxmlformats.org/presentationml/2006/main" showMasterSp="0" showMasterPhAnim="0">
   <p:cSld>
     <p:spTree>
@@ -1854,436 +1750,6 @@
 </file>
 
 <file path=ppt/slideLayouts/slideLayout10.xml><?xml version="1.0" encoding="utf-8"?>
-<p:sldLayout xmlns:a="http://schemas.openxmlformats.org/drawingml/2006/main" xmlns:r="http://schemas.openxmlformats.org/officeDocument/2006/relationships" xmlns:p="http://schemas.openxmlformats.org/presentationml/2006/main" matchingName="Blank" type="blank">
-  <p:cSld name="BG_S8">
-    <p:spTree>
-      <p:nvGrpSpPr>
-        <p:cNvPr id="1" name="Shape 11"/>
-        <p:cNvGrpSpPr/>
-        <p:nvPr/>
-      </p:nvGrpSpPr>
-      <p:grpSpPr>
-        <a:xfrm>
-          <a:off x="0" y="0"/>
-          <a:ext cx="0" cy="0"/>
-          <a:chOff x="0" y="0"/>
-          <a:chExt cx="0" cy="0"/>
-        </a:xfrm>
-      </p:grpSpPr>
-      <p:pic>
-        <p:nvPicPr>
-          <p:cNvPr id="900" name="BG_S8"/>
-          <p:cNvPicPr preferRelativeResize="0">
-            <a:picLocks noGrp="1" noRot="1" noChangeAspect="1" noMove="1" noResize="1" noEditPoints="1" noAdjustHandles="1" noChangeArrowheads="1" noChangeShapeType="1"/>
-          </p:cNvPicPr>
-          <p:nvPr/>
-        </p:nvPicPr>
-        <p:blipFill rotWithShape="1">
-          <a:blip r:embed="rId2">
-            <a:alphaModFix/>
-          </a:blip>
-          <a:srcRect/>
-          <a:stretch/>
-        </p:blipFill>
-        <p:spPr>
-          <a:xfrm>
-            <a:off x="0" y="0"/>
-            <a:ext cx="12192000" cy="6858000"/>
-          </a:xfrm>
-          <a:prstGeom prst="rect">
-            <a:avLst/>
-          </a:prstGeom>
-          <a:noFill/>
-          <a:ln>
-            <a:noFill/>
-          </a:ln>
-        </p:spPr>
-      </p:pic>
-      <p:sp>
-        <p:nvSpPr>
-          <p:cNvPr id="12" name="Google Shape;12;p2"/>
-          <p:cNvSpPr txBox="1">
-            <a:spLocks noGrp="1"/>
-          </p:cNvSpPr>
-          <p:nvPr>
-            <p:ph type="dt" idx="10"/>
-          </p:nvPr>
-        </p:nvSpPr>
-        <p:spPr>
-          <a:xfrm>
-            <a:off x="457200" y="6356350"/>
-            <a:ext cx="2133600" cy="365125"/>
-          </a:xfrm>
-          <a:prstGeom prst="rect">
-            <a:avLst/>
-          </a:prstGeom>
-          <a:noFill/>
-          <a:ln>
-            <a:noFill/>
-          </a:ln>
-        </p:spPr>
-        <p:txBody>
-          <a:bodyPr spcFirstLastPara="1" wrap="square" lIns="91425" tIns="45700" rIns="91425" bIns="45700" anchor="ctr" anchorCtr="0">
-            <a:noAutofit/>
-          </a:bodyPr>
-          <a:lstStyle>
-            <a:lvl1pPr lvl="0" algn="l">
-              <a:spcBef>
-                <a:spcPts val="0"/>
-              </a:spcBef>
-              <a:spcAft>
-                <a:spcPts val="0"/>
-              </a:spcAft>
-              <a:buSzPts val="1400"/>
-              <a:buNone/>
-              <a:defRPr/>
-            </a:lvl1pPr>
-            <a:lvl2pPr lvl="1" algn="l">
-              <a:spcBef>
-                <a:spcPts val="0"/>
-              </a:spcBef>
-              <a:spcAft>
-                <a:spcPts val="0"/>
-              </a:spcAft>
-              <a:buSzPts val="1400"/>
-              <a:buNone/>
-              <a:defRPr/>
-            </a:lvl2pPr>
-            <a:lvl3pPr lvl="2" algn="l">
-              <a:spcBef>
-                <a:spcPts val="0"/>
-              </a:spcBef>
-              <a:spcAft>
-                <a:spcPts val="0"/>
-              </a:spcAft>
-              <a:buSzPts val="1400"/>
-              <a:buNone/>
-              <a:defRPr/>
-            </a:lvl3pPr>
-            <a:lvl4pPr lvl="3" algn="l">
-              <a:spcBef>
-                <a:spcPts val="0"/>
-              </a:spcBef>
-              <a:spcAft>
-                <a:spcPts val="0"/>
-              </a:spcAft>
-              <a:buSzPts val="1400"/>
-              <a:buNone/>
-              <a:defRPr/>
-            </a:lvl4pPr>
-            <a:lvl5pPr lvl="4" algn="l">
-              <a:spcBef>
-                <a:spcPts val="0"/>
-              </a:spcBef>
-              <a:spcAft>
-                <a:spcPts val="0"/>
-              </a:spcAft>
-              <a:buSzPts val="1400"/>
-              <a:buNone/>
-              <a:defRPr/>
-            </a:lvl5pPr>
-            <a:lvl6pPr lvl="5" algn="l">
-              <a:spcBef>
-                <a:spcPts val="0"/>
-              </a:spcBef>
-              <a:spcAft>
-                <a:spcPts val="0"/>
-              </a:spcAft>
-              <a:buSzPts val="1400"/>
-              <a:buNone/>
-              <a:defRPr/>
-            </a:lvl6pPr>
-            <a:lvl7pPr lvl="6" algn="l">
-              <a:spcBef>
-                <a:spcPts val="0"/>
-              </a:spcBef>
-              <a:spcAft>
-                <a:spcPts val="0"/>
-              </a:spcAft>
-              <a:buSzPts val="1400"/>
-              <a:buNone/>
-              <a:defRPr/>
-            </a:lvl7pPr>
-            <a:lvl8pPr lvl="7" algn="l">
-              <a:spcBef>
-                <a:spcPts val="0"/>
-              </a:spcBef>
-              <a:spcAft>
-                <a:spcPts val="0"/>
-              </a:spcAft>
-              <a:buSzPts val="1400"/>
-              <a:buNone/>
-              <a:defRPr/>
-            </a:lvl8pPr>
-            <a:lvl9pPr lvl="8" algn="l">
-              <a:spcBef>
-                <a:spcPts val="0"/>
-              </a:spcBef>
-              <a:spcAft>
-                <a:spcPts val="0"/>
-              </a:spcAft>
-              <a:buSzPts val="1400"/>
-              <a:buNone/>
-              <a:defRPr/>
-            </a:lvl9pPr>
-          </a:lstStyle>
-          <a:p>
-            <a:endParaRPr/>
-          </a:p>
-        </p:txBody>
-      </p:sp>
-      <p:sp>
-        <p:nvSpPr>
-          <p:cNvPr id="13" name="Google Shape;13;p2"/>
-          <p:cNvSpPr txBox="1">
-            <a:spLocks noGrp="1"/>
-          </p:cNvSpPr>
-          <p:nvPr>
-            <p:ph type="ftr" idx="11"/>
-          </p:nvPr>
-        </p:nvSpPr>
-        <p:spPr>
-          <a:xfrm>
-            <a:off x="3124200" y="6356350"/>
-            <a:ext cx="2895600" cy="365125"/>
-          </a:xfrm>
-          <a:prstGeom prst="rect">
-            <a:avLst/>
-          </a:prstGeom>
-          <a:noFill/>
-          <a:ln>
-            <a:noFill/>
-          </a:ln>
-        </p:spPr>
-        <p:txBody>
-          <a:bodyPr spcFirstLastPara="1" wrap="square" lIns="91425" tIns="45700" rIns="91425" bIns="45700" anchor="ctr" anchorCtr="0">
-            <a:noAutofit/>
-          </a:bodyPr>
-          <a:lstStyle>
-            <a:lvl1pPr lvl="0" algn="ctr">
-              <a:spcBef>
-                <a:spcPts val="0"/>
-              </a:spcBef>
-              <a:spcAft>
-                <a:spcPts val="0"/>
-              </a:spcAft>
-              <a:buSzPts val="1400"/>
-              <a:buNone/>
-              <a:defRPr/>
-            </a:lvl1pPr>
-            <a:lvl2pPr lvl="1" algn="l">
-              <a:spcBef>
-                <a:spcPts val="0"/>
-              </a:spcBef>
-              <a:spcAft>
-                <a:spcPts val="0"/>
-              </a:spcAft>
-              <a:buSzPts val="1400"/>
-              <a:buNone/>
-              <a:defRPr/>
-            </a:lvl2pPr>
-            <a:lvl3pPr lvl="2" algn="l">
-              <a:spcBef>
-                <a:spcPts val="0"/>
-              </a:spcBef>
-              <a:spcAft>
-                <a:spcPts val="0"/>
-              </a:spcAft>
-              <a:buSzPts val="1400"/>
-              <a:buNone/>
-              <a:defRPr/>
-            </a:lvl3pPr>
-            <a:lvl4pPr lvl="3" algn="l">
-              <a:spcBef>
-                <a:spcPts val="0"/>
-              </a:spcBef>
-              <a:spcAft>
-                <a:spcPts val="0"/>
-              </a:spcAft>
-              <a:buSzPts val="1400"/>
-              <a:buNone/>
-              <a:defRPr/>
-            </a:lvl4pPr>
-            <a:lvl5pPr lvl="4" algn="l">
-              <a:spcBef>
-                <a:spcPts val="0"/>
-              </a:spcBef>
-              <a:spcAft>
-                <a:spcPts val="0"/>
-              </a:spcAft>
-              <a:buSzPts val="1400"/>
-              <a:buNone/>
-              <a:defRPr/>
-            </a:lvl5pPr>
-            <a:lvl6pPr lvl="5" algn="l">
-              <a:spcBef>
-                <a:spcPts val="0"/>
-              </a:spcBef>
-              <a:spcAft>
-                <a:spcPts val="0"/>
-              </a:spcAft>
-              <a:buSzPts val="1400"/>
-              <a:buNone/>
-              <a:defRPr/>
-            </a:lvl6pPr>
-            <a:lvl7pPr lvl="6" algn="l">
-              <a:spcBef>
-                <a:spcPts val="0"/>
-              </a:spcBef>
-              <a:spcAft>
-                <a:spcPts val="0"/>
-              </a:spcAft>
-              <a:buSzPts val="1400"/>
-              <a:buNone/>
-              <a:defRPr/>
-            </a:lvl7pPr>
-            <a:lvl8pPr lvl="7" algn="l">
-              <a:spcBef>
-                <a:spcPts val="0"/>
-              </a:spcBef>
-              <a:spcAft>
-                <a:spcPts val="0"/>
-              </a:spcAft>
-              <a:buSzPts val="1400"/>
-              <a:buNone/>
-              <a:defRPr/>
-            </a:lvl8pPr>
-            <a:lvl9pPr lvl="8" algn="l">
-              <a:spcBef>
-                <a:spcPts val="0"/>
-              </a:spcBef>
-              <a:spcAft>
-                <a:spcPts val="0"/>
-              </a:spcAft>
-              <a:buSzPts val="1400"/>
-              <a:buNone/>
-              <a:defRPr/>
-            </a:lvl9pPr>
-          </a:lstStyle>
-          <a:p>
-            <a:endParaRPr/>
-          </a:p>
-        </p:txBody>
-      </p:sp>
-      <p:sp>
-        <p:nvSpPr>
-          <p:cNvPr id="14" name="Google Shape;14;p2"/>
-          <p:cNvSpPr txBox="1">
-            <a:spLocks noGrp="1"/>
-          </p:cNvSpPr>
-          <p:nvPr>
-            <p:ph type="sldNum" idx="12"/>
-          </p:nvPr>
-        </p:nvSpPr>
-        <p:spPr>
-          <a:xfrm>
-            <a:off x="6553200" y="6356350"/>
-            <a:ext cx="2133600" cy="365125"/>
-          </a:xfrm>
-          <a:prstGeom prst="rect">
-            <a:avLst/>
-          </a:prstGeom>
-          <a:noFill/>
-          <a:ln>
-            <a:noFill/>
-          </a:ln>
-        </p:spPr>
-        <p:txBody>
-          <a:bodyPr spcFirstLastPara="1" wrap="square" lIns="91425" tIns="45700" rIns="91425" bIns="45700" anchor="ctr" anchorCtr="0">
-            <a:noAutofit/>
-          </a:bodyPr>
-          <a:lstStyle>
-            <a:lvl1pPr marL="0" lvl="0" indent="0" algn="r">
-              <a:spcBef>
-                <a:spcPts val="0"/>
-              </a:spcBef>
-              <a:buNone/>
-              <a:defRPr/>
-            </a:lvl1pPr>
-            <a:lvl2pPr marL="0" lvl="1" indent="0" algn="r">
-              <a:spcBef>
-                <a:spcPts val="0"/>
-              </a:spcBef>
-              <a:buNone/>
-              <a:defRPr/>
-            </a:lvl2pPr>
-            <a:lvl3pPr marL="0" lvl="2" indent="0" algn="r">
-              <a:spcBef>
-                <a:spcPts val="0"/>
-              </a:spcBef>
-              <a:buNone/>
-              <a:defRPr/>
-            </a:lvl3pPr>
-            <a:lvl4pPr marL="0" lvl="3" indent="0" algn="r">
-              <a:spcBef>
-                <a:spcPts val="0"/>
-              </a:spcBef>
-              <a:buNone/>
-              <a:defRPr/>
-            </a:lvl4pPr>
-            <a:lvl5pPr marL="0" lvl="4" indent="0" algn="r">
-              <a:spcBef>
-                <a:spcPts val="0"/>
-              </a:spcBef>
-              <a:buNone/>
-              <a:defRPr/>
-            </a:lvl5pPr>
-            <a:lvl6pPr marL="0" lvl="5" indent="0" algn="r">
-              <a:spcBef>
-                <a:spcPts val="0"/>
-              </a:spcBef>
-              <a:buNone/>
-              <a:defRPr/>
-            </a:lvl6pPr>
-            <a:lvl7pPr marL="0" lvl="6" indent="0" algn="r">
-              <a:spcBef>
-                <a:spcPts val="0"/>
-              </a:spcBef>
-              <a:buNone/>
-              <a:defRPr/>
-            </a:lvl7pPr>
-            <a:lvl8pPr marL="0" lvl="7" indent="0" algn="r">
-              <a:spcBef>
-                <a:spcPts val="0"/>
-              </a:spcBef>
-              <a:buNone/>
-              <a:defRPr/>
-            </a:lvl8pPr>
-            <a:lvl9pPr marL="0" lvl="8" indent="0" algn="r">
-              <a:spcBef>
-                <a:spcPts val="0"/>
-              </a:spcBef>
-              <a:buNone/>
-              <a:defRPr/>
-            </a:lvl9pPr>
-          </a:lstStyle>
-          <a:p>
-            <a:pPr marL="0" lvl="0" indent="0" algn="r" rtl="0">
-              <a:spcBef>
-                <a:spcPts val="0"/>
-              </a:spcBef>
-              <a:spcAft>
-                <a:spcPts val="0"/>
-              </a:spcAft>
-              <a:buNone/>
-            </a:pPr>
-            <a:fld id="{00000000-1234-1234-1234-123412341234}" type="slidenum">
-              <a:rPr lang="en-US"/>
-              <a:t>‹#›</a:t>
-            </a:fld>
-            <a:endParaRPr/>
-          </a:p>
-        </p:txBody>
-      </p:sp>
-    </p:spTree>
-  </p:cSld>
-  <p:clrMapOvr>
-    <a:masterClrMapping/>
-  </p:clrMapOvr>
-</p:sldLayout>
-</file>
-
-<file path=ppt/slideLayouts/slideLayout11.xml><?xml version="1.0" encoding="utf-8"?>
 <p:sldLayout xmlns:a="http://schemas.openxmlformats.org/drawingml/2006/main" xmlns:r="http://schemas.openxmlformats.org/officeDocument/2006/relationships" xmlns:p="http://schemas.openxmlformats.org/presentationml/2006/main" matchingName="Vertical Title and Text" type="vertTitleAndTx">
   <p:cSld name="VERTICAL_TITLE_AND_VERTICAL_TEXT">
     <p:spTree>
@@ -4969,436 +4435,6 @@
 
 <file path=ppt/slideLayouts/slideLayout6.xml><?xml version="1.0" encoding="utf-8"?>
 <p:sldLayout xmlns:a="http://schemas.openxmlformats.org/drawingml/2006/main" xmlns:r="http://schemas.openxmlformats.org/officeDocument/2006/relationships" xmlns:p="http://schemas.openxmlformats.org/presentationml/2006/main" matchingName="Blank" type="blank">
-  <p:cSld name="BG_S4">
-    <p:spTree>
-      <p:nvGrpSpPr>
-        <p:cNvPr id="1" name="Shape 11"/>
-        <p:cNvGrpSpPr/>
-        <p:nvPr/>
-      </p:nvGrpSpPr>
-      <p:grpSpPr>
-        <a:xfrm>
-          <a:off x="0" y="0"/>
-          <a:ext cx="0" cy="0"/>
-          <a:chOff x="0" y="0"/>
-          <a:chExt cx="0" cy="0"/>
-        </a:xfrm>
-      </p:grpSpPr>
-      <p:pic>
-        <p:nvPicPr>
-          <p:cNvPr id="900" name="BG_S4"/>
-          <p:cNvPicPr preferRelativeResize="0">
-            <a:picLocks noGrp="1" noRot="1" noChangeAspect="1" noMove="1" noResize="1" noEditPoints="1" noAdjustHandles="1" noChangeArrowheads="1" noChangeShapeType="1"/>
-          </p:cNvPicPr>
-          <p:nvPr/>
-        </p:nvPicPr>
-        <p:blipFill rotWithShape="1">
-          <a:blip r:embed="rId2">
-            <a:alphaModFix/>
-          </a:blip>
-          <a:srcRect/>
-          <a:stretch/>
-        </p:blipFill>
-        <p:spPr>
-          <a:xfrm>
-            <a:off x="0" y="0"/>
-            <a:ext cx="12192000" cy="6858000"/>
-          </a:xfrm>
-          <a:prstGeom prst="rect">
-            <a:avLst/>
-          </a:prstGeom>
-          <a:noFill/>
-          <a:ln>
-            <a:noFill/>
-          </a:ln>
-        </p:spPr>
-      </p:pic>
-      <p:sp>
-        <p:nvSpPr>
-          <p:cNvPr id="12" name="Google Shape;12;p2"/>
-          <p:cNvSpPr txBox="1">
-            <a:spLocks noGrp="1"/>
-          </p:cNvSpPr>
-          <p:nvPr>
-            <p:ph type="dt" idx="10"/>
-          </p:nvPr>
-        </p:nvSpPr>
-        <p:spPr>
-          <a:xfrm>
-            <a:off x="457200" y="6356350"/>
-            <a:ext cx="2133600" cy="365125"/>
-          </a:xfrm>
-          <a:prstGeom prst="rect">
-            <a:avLst/>
-          </a:prstGeom>
-          <a:noFill/>
-          <a:ln>
-            <a:noFill/>
-          </a:ln>
-        </p:spPr>
-        <p:txBody>
-          <a:bodyPr spcFirstLastPara="1" wrap="square" lIns="91425" tIns="45700" rIns="91425" bIns="45700" anchor="ctr" anchorCtr="0">
-            <a:noAutofit/>
-          </a:bodyPr>
-          <a:lstStyle>
-            <a:lvl1pPr lvl="0" algn="l">
-              <a:spcBef>
-                <a:spcPts val="0"/>
-              </a:spcBef>
-              <a:spcAft>
-                <a:spcPts val="0"/>
-              </a:spcAft>
-              <a:buSzPts val="1400"/>
-              <a:buNone/>
-              <a:defRPr/>
-            </a:lvl1pPr>
-            <a:lvl2pPr lvl="1" algn="l">
-              <a:spcBef>
-                <a:spcPts val="0"/>
-              </a:spcBef>
-              <a:spcAft>
-                <a:spcPts val="0"/>
-              </a:spcAft>
-              <a:buSzPts val="1400"/>
-              <a:buNone/>
-              <a:defRPr/>
-            </a:lvl2pPr>
-            <a:lvl3pPr lvl="2" algn="l">
-              <a:spcBef>
-                <a:spcPts val="0"/>
-              </a:spcBef>
-              <a:spcAft>
-                <a:spcPts val="0"/>
-              </a:spcAft>
-              <a:buSzPts val="1400"/>
-              <a:buNone/>
-              <a:defRPr/>
-            </a:lvl3pPr>
-            <a:lvl4pPr lvl="3" algn="l">
-              <a:spcBef>
-                <a:spcPts val="0"/>
-              </a:spcBef>
-              <a:spcAft>
-                <a:spcPts val="0"/>
-              </a:spcAft>
-              <a:buSzPts val="1400"/>
-              <a:buNone/>
-              <a:defRPr/>
-            </a:lvl4pPr>
-            <a:lvl5pPr lvl="4" algn="l">
-              <a:spcBef>
-                <a:spcPts val="0"/>
-              </a:spcBef>
-              <a:spcAft>
-                <a:spcPts val="0"/>
-              </a:spcAft>
-              <a:buSzPts val="1400"/>
-              <a:buNone/>
-              <a:defRPr/>
-            </a:lvl5pPr>
-            <a:lvl6pPr lvl="5" algn="l">
-              <a:spcBef>
-                <a:spcPts val="0"/>
-              </a:spcBef>
-              <a:spcAft>
-                <a:spcPts val="0"/>
-              </a:spcAft>
-              <a:buSzPts val="1400"/>
-              <a:buNone/>
-              <a:defRPr/>
-            </a:lvl6pPr>
-            <a:lvl7pPr lvl="6" algn="l">
-              <a:spcBef>
-                <a:spcPts val="0"/>
-              </a:spcBef>
-              <a:spcAft>
-                <a:spcPts val="0"/>
-              </a:spcAft>
-              <a:buSzPts val="1400"/>
-              <a:buNone/>
-              <a:defRPr/>
-            </a:lvl7pPr>
-            <a:lvl8pPr lvl="7" algn="l">
-              <a:spcBef>
-                <a:spcPts val="0"/>
-              </a:spcBef>
-              <a:spcAft>
-                <a:spcPts val="0"/>
-              </a:spcAft>
-              <a:buSzPts val="1400"/>
-              <a:buNone/>
-              <a:defRPr/>
-            </a:lvl8pPr>
-            <a:lvl9pPr lvl="8" algn="l">
-              <a:spcBef>
-                <a:spcPts val="0"/>
-              </a:spcBef>
-              <a:spcAft>
-                <a:spcPts val="0"/>
-              </a:spcAft>
-              <a:buSzPts val="1400"/>
-              <a:buNone/>
-              <a:defRPr/>
-            </a:lvl9pPr>
-          </a:lstStyle>
-          <a:p>
-            <a:endParaRPr/>
-          </a:p>
-        </p:txBody>
-      </p:sp>
-      <p:sp>
-        <p:nvSpPr>
-          <p:cNvPr id="13" name="Google Shape;13;p2"/>
-          <p:cNvSpPr txBox="1">
-            <a:spLocks noGrp="1"/>
-          </p:cNvSpPr>
-          <p:nvPr>
-            <p:ph type="ftr" idx="11"/>
-          </p:nvPr>
-        </p:nvSpPr>
-        <p:spPr>
-          <a:xfrm>
-            <a:off x="3124200" y="6356350"/>
-            <a:ext cx="2895600" cy="365125"/>
-          </a:xfrm>
-          <a:prstGeom prst="rect">
-            <a:avLst/>
-          </a:prstGeom>
-          <a:noFill/>
-          <a:ln>
-            <a:noFill/>
-          </a:ln>
-        </p:spPr>
-        <p:txBody>
-          <a:bodyPr spcFirstLastPara="1" wrap="square" lIns="91425" tIns="45700" rIns="91425" bIns="45700" anchor="ctr" anchorCtr="0">
-            <a:noAutofit/>
-          </a:bodyPr>
-          <a:lstStyle>
-            <a:lvl1pPr lvl="0" algn="ctr">
-              <a:spcBef>
-                <a:spcPts val="0"/>
-              </a:spcBef>
-              <a:spcAft>
-                <a:spcPts val="0"/>
-              </a:spcAft>
-              <a:buSzPts val="1400"/>
-              <a:buNone/>
-              <a:defRPr/>
-            </a:lvl1pPr>
-            <a:lvl2pPr lvl="1" algn="l">
-              <a:spcBef>
-                <a:spcPts val="0"/>
-              </a:spcBef>
-              <a:spcAft>
-                <a:spcPts val="0"/>
-              </a:spcAft>
-              <a:buSzPts val="1400"/>
-              <a:buNone/>
-              <a:defRPr/>
-            </a:lvl2pPr>
-            <a:lvl3pPr lvl="2" algn="l">
-              <a:spcBef>
-                <a:spcPts val="0"/>
-              </a:spcBef>
-              <a:spcAft>
-                <a:spcPts val="0"/>
-              </a:spcAft>
-              <a:buSzPts val="1400"/>
-              <a:buNone/>
-              <a:defRPr/>
-            </a:lvl3pPr>
-            <a:lvl4pPr lvl="3" algn="l">
-              <a:spcBef>
-                <a:spcPts val="0"/>
-              </a:spcBef>
-              <a:spcAft>
-                <a:spcPts val="0"/>
-              </a:spcAft>
-              <a:buSzPts val="1400"/>
-              <a:buNone/>
-              <a:defRPr/>
-            </a:lvl4pPr>
-            <a:lvl5pPr lvl="4" algn="l">
-              <a:spcBef>
-                <a:spcPts val="0"/>
-              </a:spcBef>
-              <a:spcAft>
-                <a:spcPts val="0"/>
-              </a:spcAft>
-              <a:buSzPts val="1400"/>
-              <a:buNone/>
-              <a:defRPr/>
-            </a:lvl5pPr>
-            <a:lvl6pPr lvl="5" algn="l">
-              <a:spcBef>
-                <a:spcPts val="0"/>
-              </a:spcBef>
-              <a:spcAft>
-                <a:spcPts val="0"/>
-              </a:spcAft>
-              <a:buSzPts val="1400"/>
-              <a:buNone/>
-              <a:defRPr/>
-            </a:lvl6pPr>
-            <a:lvl7pPr lvl="6" algn="l">
-              <a:spcBef>
-                <a:spcPts val="0"/>
-              </a:spcBef>
-              <a:spcAft>
-                <a:spcPts val="0"/>
-              </a:spcAft>
-              <a:buSzPts val="1400"/>
-              <a:buNone/>
-              <a:defRPr/>
-            </a:lvl7pPr>
-            <a:lvl8pPr lvl="7" algn="l">
-              <a:spcBef>
-                <a:spcPts val="0"/>
-              </a:spcBef>
-              <a:spcAft>
-                <a:spcPts val="0"/>
-              </a:spcAft>
-              <a:buSzPts val="1400"/>
-              <a:buNone/>
-              <a:defRPr/>
-            </a:lvl8pPr>
-            <a:lvl9pPr lvl="8" algn="l">
-              <a:spcBef>
-                <a:spcPts val="0"/>
-              </a:spcBef>
-              <a:spcAft>
-                <a:spcPts val="0"/>
-              </a:spcAft>
-              <a:buSzPts val="1400"/>
-              <a:buNone/>
-              <a:defRPr/>
-            </a:lvl9pPr>
-          </a:lstStyle>
-          <a:p>
-            <a:endParaRPr/>
-          </a:p>
-        </p:txBody>
-      </p:sp>
-      <p:sp>
-        <p:nvSpPr>
-          <p:cNvPr id="14" name="Google Shape;14;p2"/>
-          <p:cNvSpPr txBox="1">
-            <a:spLocks noGrp="1"/>
-          </p:cNvSpPr>
-          <p:nvPr>
-            <p:ph type="sldNum" idx="12"/>
-          </p:nvPr>
-        </p:nvSpPr>
-        <p:spPr>
-          <a:xfrm>
-            <a:off x="6553200" y="6356350"/>
-            <a:ext cx="2133600" cy="365125"/>
-          </a:xfrm>
-          <a:prstGeom prst="rect">
-            <a:avLst/>
-          </a:prstGeom>
-          <a:noFill/>
-          <a:ln>
-            <a:noFill/>
-          </a:ln>
-        </p:spPr>
-        <p:txBody>
-          <a:bodyPr spcFirstLastPara="1" wrap="square" lIns="91425" tIns="45700" rIns="91425" bIns="45700" anchor="ctr" anchorCtr="0">
-            <a:noAutofit/>
-          </a:bodyPr>
-          <a:lstStyle>
-            <a:lvl1pPr marL="0" lvl="0" indent="0" algn="r">
-              <a:spcBef>
-                <a:spcPts val="0"/>
-              </a:spcBef>
-              <a:buNone/>
-              <a:defRPr/>
-            </a:lvl1pPr>
-            <a:lvl2pPr marL="0" lvl="1" indent="0" algn="r">
-              <a:spcBef>
-                <a:spcPts val="0"/>
-              </a:spcBef>
-              <a:buNone/>
-              <a:defRPr/>
-            </a:lvl2pPr>
-            <a:lvl3pPr marL="0" lvl="2" indent="0" algn="r">
-              <a:spcBef>
-                <a:spcPts val="0"/>
-              </a:spcBef>
-              <a:buNone/>
-              <a:defRPr/>
-            </a:lvl3pPr>
-            <a:lvl4pPr marL="0" lvl="3" indent="0" algn="r">
-              <a:spcBef>
-                <a:spcPts val="0"/>
-              </a:spcBef>
-              <a:buNone/>
-              <a:defRPr/>
-            </a:lvl4pPr>
-            <a:lvl5pPr marL="0" lvl="4" indent="0" algn="r">
-              <a:spcBef>
-                <a:spcPts val="0"/>
-              </a:spcBef>
-              <a:buNone/>
-              <a:defRPr/>
-            </a:lvl5pPr>
-            <a:lvl6pPr marL="0" lvl="5" indent="0" algn="r">
-              <a:spcBef>
-                <a:spcPts val="0"/>
-              </a:spcBef>
-              <a:buNone/>
-              <a:defRPr/>
-            </a:lvl6pPr>
-            <a:lvl7pPr marL="0" lvl="6" indent="0" algn="r">
-              <a:spcBef>
-                <a:spcPts val="0"/>
-              </a:spcBef>
-              <a:buNone/>
-              <a:defRPr/>
-            </a:lvl7pPr>
-            <a:lvl8pPr marL="0" lvl="7" indent="0" algn="r">
-              <a:spcBef>
-                <a:spcPts val="0"/>
-              </a:spcBef>
-              <a:buNone/>
-              <a:defRPr/>
-            </a:lvl8pPr>
-            <a:lvl9pPr marL="0" lvl="8" indent="0" algn="r">
-              <a:spcBef>
-                <a:spcPts val="0"/>
-              </a:spcBef>
-              <a:buNone/>
-              <a:defRPr/>
-            </a:lvl9pPr>
-          </a:lstStyle>
-          <a:p>
-            <a:pPr marL="0" lvl="0" indent="0" algn="r" rtl="0">
-              <a:spcBef>
-                <a:spcPts val="0"/>
-              </a:spcBef>
-              <a:spcAft>
-                <a:spcPts val="0"/>
-              </a:spcAft>
-              <a:buNone/>
-            </a:pPr>
-            <a:fld id="{00000000-1234-1234-1234-123412341234}" type="slidenum">
-              <a:rPr lang="en-US"/>
-              <a:t>‹#›</a:t>
-            </a:fld>
-            <a:endParaRPr/>
-          </a:p>
-        </p:txBody>
-      </p:sp>
-    </p:spTree>
-  </p:cSld>
-  <p:clrMapOvr>
-    <a:masterClrMapping/>
-  </p:clrMapOvr>
-</p:sldLayout>
-</file>
-
-<file path=ppt/slideLayouts/slideLayout7.xml><?xml version="1.0" encoding="utf-8"?>
-<p:sldLayout xmlns:a="http://schemas.openxmlformats.org/drawingml/2006/main" xmlns:r="http://schemas.openxmlformats.org/officeDocument/2006/relationships" xmlns:p="http://schemas.openxmlformats.org/presentationml/2006/main" matchingName="Blank" type="blank">
   <p:cSld name="BG_S5">
     <p:spTree>
       <p:nvGrpSpPr>
@@ -5827,7 +4863,7 @@
 </p:sldLayout>
 </file>
 
-<file path=ppt/slideLayouts/slideLayout8.xml><?xml version="1.0" encoding="utf-8"?>
+<file path=ppt/slideLayouts/slideLayout7.xml><?xml version="1.0" encoding="utf-8"?>
 <p:sldLayout xmlns:a="http://schemas.openxmlformats.org/drawingml/2006/main" xmlns:r="http://schemas.openxmlformats.org/officeDocument/2006/relationships" xmlns:p="http://schemas.openxmlformats.org/presentationml/2006/main" matchingName="Blank" type="blank">
   <p:cSld name="BG_S6">
     <p:spTree>
@@ -6257,7 +5293,7 @@
 </p:sldLayout>
 </file>
 
-<file path=ppt/slideLayouts/slideLayout9.xml><?xml version="1.0" encoding="utf-8"?>
+<file path=ppt/slideLayouts/slideLayout8.xml><?xml version="1.0" encoding="utf-8"?>
 <p:sldLayout xmlns:a="http://schemas.openxmlformats.org/drawingml/2006/main" xmlns:r="http://schemas.openxmlformats.org/officeDocument/2006/relationships" xmlns:p="http://schemas.openxmlformats.org/presentationml/2006/main" matchingName="Title and Content" type="obj">
   <p:cSld name="BG_S7">
     <p:spTree>
@@ -6983,6 +6019,436 @@
 </p:sldLayout>
 </file>
 
+<file path=ppt/slideLayouts/slideLayout9.xml><?xml version="1.0" encoding="utf-8"?>
+<p:sldLayout xmlns:a="http://schemas.openxmlformats.org/drawingml/2006/main" xmlns:r="http://schemas.openxmlformats.org/officeDocument/2006/relationships" xmlns:p="http://schemas.openxmlformats.org/presentationml/2006/main" matchingName="Blank" type="blank">
+  <p:cSld name="BG_S8">
+    <p:spTree>
+      <p:nvGrpSpPr>
+        <p:cNvPr id="1" name="Shape 11"/>
+        <p:cNvGrpSpPr/>
+        <p:nvPr/>
+      </p:nvGrpSpPr>
+      <p:grpSpPr>
+        <a:xfrm>
+          <a:off x="0" y="0"/>
+          <a:ext cx="0" cy="0"/>
+          <a:chOff x="0" y="0"/>
+          <a:chExt cx="0" cy="0"/>
+        </a:xfrm>
+      </p:grpSpPr>
+      <p:pic>
+        <p:nvPicPr>
+          <p:cNvPr id="900" name="BG_S8"/>
+          <p:cNvPicPr preferRelativeResize="0">
+            <a:picLocks noGrp="1" noRot="1" noChangeAspect="1" noMove="1" noResize="1" noEditPoints="1" noAdjustHandles="1" noChangeArrowheads="1" noChangeShapeType="1"/>
+          </p:cNvPicPr>
+          <p:nvPr/>
+        </p:nvPicPr>
+        <p:blipFill rotWithShape="1">
+          <a:blip r:embed="rId2">
+            <a:alphaModFix/>
+          </a:blip>
+          <a:srcRect/>
+          <a:stretch/>
+        </p:blipFill>
+        <p:spPr>
+          <a:xfrm>
+            <a:off x="0" y="0"/>
+            <a:ext cx="12192000" cy="6858000"/>
+          </a:xfrm>
+          <a:prstGeom prst="rect">
+            <a:avLst/>
+          </a:prstGeom>
+          <a:noFill/>
+          <a:ln>
+            <a:noFill/>
+          </a:ln>
+        </p:spPr>
+      </p:pic>
+      <p:sp>
+        <p:nvSpPr>
+          <p:cNvPr id="12" name="Google Shape;12;p2"/>
+          <p:cNvSpPr txBox="1">
+            <a:spLocks noGrp="1"/>
+          </p:cNvSpPr>
+          <p:nvPr>
+            <p:ph type="dt" idx="10"/>
+          </p:nvPr>
+        </p:nvSpPr>
+        <p:spPr>
+          <a:xfrm>
+            <a:off x="457200" y="6356350"/>
+            <a:ext cx="2133600" cy="365125"/>
+          </a:xfrm>
+          <a:prstGeom prst="rect">
+            <a:avLst/>
+          </a:prstGeom>
+          <a:noFill/>
+          <a:ln>
+            <a:noFill/>
+          </a:ln>
+        </p:spPr>
+        <p:txBody>
+          <a:bodyPr spcFirstLastPara="1" wrap="square" lIns="91425" tIns="45700" rIns="91425" bIns="45700" anchor="ctr" anchorCtr="0">
+            <a:noAutofit/>
+          </a:bodyPr>
+          <a:lstStyle>
+            <a:lvl1pPr lvl="0" algn="l">
+              <a:spcBef>
+                <a:spcPts val="0"/>
+              </a:spcBef>
+              <a:spcAft>
+                <a:spcPts val="0"/>
+              </a:spcAft>
+              <a:buSzPts val="1400"/>
+              <a:buNone/>
+              <a:defRPr/>
+            </a:lvl1pPr>
+            <a:lvl2pPr lvl="1" algn="l">
+              <a:spcBef>
+                <a:spcPts val="0"/>
+              </a:spcBef>
+              <a:spcAft>
+                <a:spcPts val="0"/>
+              </a:spcAft>
+              <a:buSzPts val="1400"/>
+              <a:buNone/>
+              <a:defRPr/>
+            </a:lvl2pPr>
+            <a:lvl3pPr lvl="2" algn="l">
+              <a:spcBef>
+                <a:spcPts val="0"/>
+              </a:spcBef>
+              <a:spcAft>
+                <a:spcPts val="0"/>
+              </a:spcAft>
+              <a:buSzPts val="1400"/>
+              <a:buNone/>
+              <a:defRPr/>
+            </a:lvl3pPr>
+            <a:lvl4pPr lvl="3" algn="l">
+              <a:spcBef>
+                <a:spcPts val="0"/>
+              </a:spcBef>
+              <a:spcAft>
+                <a:spcPts val="0"/>
+              </a:spcAft>
+              <a:buSzPts val="1400"/>
+              <a:buNone/>
+              <a:defRPr/>
+            </a:lvl4pPr>
+            <a:lvl5pPr lvl="4" algn="l">
+              <a:spcBef>
+                <a:spcPts val="0"/>
+              </a:spcBef>
+              <a:spcAft>
+                <a:spcPts val="0"/>
+              </a:spcAft>
+              <a:buSzPts val="1400"/>
+              <a:buNone/>
+              <a:defRPr/>
+            </a:lvl5pPr>
+            <a:lvl6pPr lvl="5" algn="l">
+              <a:spcBef>
+                <a:spcPts val="0"/>
+              </a:spcBef>
+              <a:spcAft>
+                <a:spcPts val="0"/>
+              </a:spcAft>
+              <a:buSzPts val="1400"/>
+              <a:buNone/>
+              <a:defRPr/>
+            </a:lvl6pPr>
+            <a:lvl7pPr lvl="6" algn="l">
+              <a:spcBef>
+                <a:spcPts val="0"/>
+              </a:spcBef>
+              <a:spcAft>
+                <a:spcPts val="0"/>
+              </a:spcAft>
+              <a:buSzPts val="1400"/>
+              <a:buNone/>
+              <a:defRPr/>
+            </a:lvl7pPr>
+            <a:lvl8pPr lvl="7" algn="l">
+              <a:spcBef>
+                <a:spcPts val="0"/>
+              </a:spcBef>
+              <a:spcAft>
+                <a:spcPts val="0"/>
+              </a:spcAft>
+              <a:buSzPts val="1400"/>
+              <a:buNone/>
+              <a:defRPr/>
+            </a:lvl8pPr>
+            <a:lvl9pPr lvl="8" algn="l">
+              <a:spcBef>
+                <a:spcPts val="0"/>
+              </a:spcBef>
+              <a:spcAft>
+                <a:spcPts val="0"/>
+              </a:spcAft>
+              <a:buSzPts val="1400"/>
+              <a:buNone/>
+              <a:defRPr/>
+            </a:lvl9pPr>
+          </a:lstStyle>
+          <a:p>
+            <a:endParaRPr/>
+          </a:p>
+        </p:txBody>
+      </p:sp>
+      <p:sp>
+        <p:nvSpPr>
+          <p:cNvPr id="13" name="Google Shape;13;p2"/>
+          <p:cNvSpPr txBox="1">
+            <a:spLocks noGrp="1"/>
+          </p:cNvSpPr>
+          <p:nvPr>
+            <p:ph type="ftr" idx="11"/>
+          </p:nvPr>
+        </p:nvSpPr>
+        <p:spPr>
+          <a:xfrm>
+            <a:off x="3124200" y="6356350"/>
+            <a:ext cx="2895600" cy="365125"/>
+          </a:xfrm>
+          <a:prstGeom prst="rect">
+            <a:avLst/>
+          </a:prstGeom>
+          <a:noFill/>
+          <a:ln>
+            <a:noFill/>
+          </a:ln>
+        </p:spPr>
+        <p:txBody>
+          <a:bodyPr spcFirstLastPara="1" wrap="square" lIns="91425" tIns="45700" rIns="91425" bIns="45700" anchor="ctr" anchorCtr="0">
+            <a:noAutofit/>
+          </a:bodyPr>
+          <a:lstStyle>
+            <a:lvl1pPr lvl="0" algn="ctr">
+              <a:spcBef>
+                <a:spcPts val="0"/>
+              </a:spcBef>
+              <a:spcAft>
+                <a:spcPts val="0"/>
+              </a:spcAft>
+              <a:buSzPts val="1400"/>
+              <a:buNone/>
+              <a:defRPr/>
+            </a:lvl1pPr>
+            <a:lvl2pPr lvl="1" algn="l">
+              <a:spcBef>
+                <a:spcPts val="0"/>
+              </a:spcBef>
+              <a:spcAft>
+                <a:spcPts val="0"/>
+              </a:spcAft>
+              <a:buSzPts val="1400"/>
+              <a:buNone/>
+              <a:defRPr/>
+            </a:lvl2pPr>
+            <a:lvl3pPr lvl="2" algn="l">
+              <a:spcBef>
+                <a:spcPts val="0"/>
+              </a:spcBef>
+              <a:spcAft>
+                <a:spcPts val="0"/>
+              </a:spcAft>
+              <a:buSzPts val="1400"/>
+              <a:buNone/>
+              <a:defRPr/>
+            </a:lvl3pPr>
+            <a:lvl4pPr lvl="3" algn="l">
+              <a:spcBef>
+                <a:spcPts val="0"/>
+              </a:spcBef>
+              <a:spcAft>
+                <a:spcPts val="0"/>
+              </a:spcAft>
+              <a:buSzPts val="1400"/>
+              <a:buNone/>
+              <a:defRPr/>
+            </a:lvl4pPr>
+            <a:lvl5pPr lvl="4" algn="l">
+              <a:spcBef>
+                <a:spcPts val="0"/>
+              </a:spcBef>
+              <a:spcAft>
+                <a:spcPts val="0"/>
+              </a:spcAft>
+              <a:buSzPts val="1400"/>
+              <a:buNone/>
+              <a:defRPr/>
+            </a:lvl5pPr>
+            <a:lvl6pPr lvl="5" algn="l">
+              <a:spcBef>
+                <a:spcPts val="0"/>
+              </a:spcBef>
+              <a:spcAft>
+                <a:spcPts val="0"/>
+              </a:spcAft>
+              <a:buSzPts val="1400"/>
+              <a:buNone/>
+              <a:defRPr/>
+            </a:lvl6pPr>
+            <a:lvl7pPr lvl="6" algn="l">
+              <a:spcBef>
+                <a:spcPts val="0"/>
+              </a:spcBef>
+              <a:spcAft>
+                <a:spcPts val="0"/>
+              </a:spcAft>
+              <a:buSzPts val="1400"/>
+              <a:buNone/>
+              <a:defRPr/>
+            </a:lvl7pPr>
+            <a:lvl8pPr lvl="7" algn="l">
+              <a:spcBef>
+                <a:spcPts val="0"/>
+              </a:spcBef>
+              <a:spcAft>
+                <a:spcPts val="0"/>
+              </a:spcAft>
+              <a:buSzPts val="1400"/>
+              <a:buNone/>
+              <a:defRPr/>
+            </a:lvl8pPr>
+            <a:lvl9pPr lvl="8" algn="l">
+              <a:spcBef>
+                <a:spcPts val="0"/>
+              </a:spcBef>
+              <a:spcAft>
+                <a:spcPts val="0"/>
+              </a:spcAft>
+              <a:buSzPts val="1400"/>
+              <a:buNone/>
+              <a:defRPr/>
+            </a:lvl9pPr>
+          </a:lstStyle>
+          <a:p>
+            <a:endParaRPr/>
+          </a:p>
+        </p:txBody>
+      </p:sp>
+      <p:sp>
+        <p:nvSpPr>
+          <p:cNvPr id="14" name="Google Shape;14;p2"/>
+          <p:cNvSpPr txBox="1">
+            <a:spLocks noGrp="1"/>
+          </p:cNvSpPr>
+          <p:nvPr>
+            <p:ph type="sldNum" idx="12"/>
+          </p:nvPr>
+        </p:nvSpPr>
+        <p:spPr>
+          <a:xfrm>
+            <a:off x="6553200" y="6356350"/>
+            <a:ext cx="2133600" cy="365125"/>
+          </a:xfrm>
+          <a:prstGeom prst="rect">
+            <a:avLst/>
+          </a:prstGeom>
+          <a:noFill/>
+          <a:ln>
+            <a:noFill/>
+          </a:ln>
+        </p:spPr>
+        <p:txBody>
+          <a:bodyPr spcFirstLastPara="1" wrap="square" lIns="91425" tIns="45700" rIns="91425" bIns="45700" anchor="ctr" anchorCtr="0">
+            <a:noAutofit/>
+          </a:bodyPr>
+          <a:lstStyle>
+            <a:lvl1pPr marL="0" lvl="0" indent="0" algn="r">
+              <a:spcBef>
+                <a:spcPts val="0"/>
+              </a:spcBef>
+              <a:buNone/>
+              <a:defRPr/>
+            </a:lvl1pPr>
+            <a:lvl2pPr marL="0" lvl="1" indent="0" algn="r">
+              <a:spcBef>
+                <a:spcPts val="0"/>
+              </a:spcBef>
+              <a:buNone/>
+              <a:defRPr/>
+            </a:lvl2pPr>
+            <a:lvl3pPr marL="0" lvl="2" indent="0" algn="r">
+              <a:spcBef>
+                <a:spcPts val="0"/>
+              </a:spcBef>
+              <a:buNone/>
+              <a:defRPr/>
+            </a:lvl3pPr>
+            <a:lvl4pPr marL="0" lvl="3" indent="0" algn="r">
+              <a:spcBef>
+                <a:spcPts val="0"/>
+              </a:spcBef>
+              <a:buNone/>
+              <a:defRPr/>
+            </a:lvl4pPr>
+            <a:lvl5pPr marL="0" lvl="4" indent="0" algn="r">
+              <a:spcBef>
+                <a:spcPts val="0"/>
+              </a:spcBef>
+              <a:buNone/>
+              <a:defRPr/>
+            </a:lvl5pPr>
+            <a:lvl6pPr marL="0" lvl="5" indent="0" algn="r">
+              <a:spcBef>
+                <a:spcPts val="0"/>
+              </a:spcBef>
+              <a:buNone/>
+              <a:defRPr/>
+            </a:lvl6pPr>
+            <a:lvl7pPr marL="0" lvl="6" indent="0" algn="r">
+              <a:spcBef>
+                <a:spcPts val="0"/>
+              </a:spcBef>
+              <a:buNone/>
+              <a:defRPr/>
+            </a:lvl7pPr>
+            <a:lvl8pPr marL="0" lvl="7" indent="0" algn="r">
+              <a:spcBef>
+                <a:spcPts val="0"/>
+              </a:spcBef>
+              <a:buNone/>
+              <a:defRPr/>
+            </a:lvl8pPr>
+            <a:lvl9pPr marL="0" lvl="8" indent="0" algn="r">
+              <a:spcBef>
+                <a:spcPts val="0"/>
+              </a:spcBef>
+              <a:buNone/>
+              <a:defRPr/>
+            </a:lvl9pPr>
+          </a:lstStyle>
+          <a:p>
+            <a:pPr marL="0" lvl="0" indent="0" algn="r" rtl="0">
+              <a:spcBef>
+                <a:spcPts val="0"/>
+              </a:spcBef>
+              <a:spcAft>
+                <a:spcPts val="0"/>
+              </a:spcAft>
+              <a:buNone/>
+            </a:pPr>
+            <a:fld id="{00000000-1234-1234-1234-123412341234}" type="slidenum">
+              <a:rPr lang="en-US"/>
+              <a:t>‹#›</a:t>
+            </a:fld>
+            <a:endParaRPr/>
+          </a:p>
+        </p:txBody>
+      </p:sp>
+    </p:spTree>
+  </p:cSld>
+  <p:clrMapOvr>
+    <a:masterClrMapping/>
+  </p:clrMapOvr>
+</p:sldLayout>
+</file>
+
 <file path=ppt/slideMasters/slideMaster1.xml><?xml version="1.0" encoding="utf-8"?>
 <p:sldMaster xmlns:a="http://schemas.openxmlformats.org/drawingml/2006/main" xmlns:r="http://schemas.openxmlformats.org/officeDocument/2006/relationships" xmlns:p="http://schemas.openxmlformats.org/presentationml/2006/main">
   <p:cSld>
@@ -7995,12 +7461,11 @@
     <p:sldLayoutId id="2147483650" r:id="rId3"/>
     <p:sldLayoutId id="2147483651" r:id="rId4"/>
     <p:sldLayoutId id="2147483652" r:id="rId5"/>
-    <p:sldLayoutId id="2147483653" r:id="rId6"/>
-    <p:sldLayoutId id="2147483654" r:id="rId7"/>
-    <p:sldLayoutId id="2147483655" r:id="rId8"/>
-    <p:sldLayoutId id="2147483656" r:id="rId9"/>
-    <p:sldLayoutId id="2147483657" r:id="rId10"/>
-    <p:sldLayoutId id="2147483658" r:id="rId11"/>
+    <p:sldLayoutId id="2147483654" r:id="rId6"/>
+    <p:sldLayoutId id="2147483655" r:id="rId7"/>
+    <p:sldLayoutId id="2147483656" r:id="rId8"/>
+    <p:sldLayoutId id="2147483657" r:id="rId9"/>
+    <p:sldLayoutId id="2147483658" r:id="rId10"/>
   </p:sldLayoutIdLst>
   <p:hf sldNum="0" hdr="0" ftr="0" dt="0"/>
   <p:txStyles>
@@ -9932,17 +9397,9 @@
 <file path=ppt/slides/slide4.xml><?xml version="1.0" encoding="utf-8"?>
 <p:sld xmlns:a="http://schemas.openxmlformats.org/drawingml/2006/main" xmlns:r="http://schemas.openxmlformats.org/officeDocument/2006/relationships" xmlns:p="http://schemas.openxmlformats.org/presentationml/2006/main">
   <p:cSld>
-    <p:bg>
-      <p:bgPr>
-        <a:solidFill>
-          <a:srgbClr val="FFFFFF"/>
-        </a:solidFill>
-        <a:effectLst/>
-      </p:bgPr>
-    </p:bg>
     <p:spTree>
       <p:nvGrpSpPr>
-        <p:cNvPr id="1" name="Shape 113"/>
+        <p:cNvPr id="1" name=""/>
         <p:cNvGrpSpPr/>
         <p:nvPr/>
       </p:nvGrpSpPr>
@@ -9956,40 +9413,29 @@
       </p:grpSpPr>
       <p:sp>
         <p:nvSpPr>
-          <p:cNvPr id="116" name="Google Shape;116;p16"/>
-          <p:cNvSpPr txBox="1"/>
-          <p:nvPr/>
+          <p:cNvPr id="2" name="Заголовок 1">
+            <a:extLst>
+              <a:ext uri="{FF2B5EF4-FFF2-40B4-BE49-F238E27FC236}">
+                <a16:creationId xmlns:a16="http://schemas.microsoft.com/office/drawing/2014/main" id="{4D31A2AF-EED1-45CB-1481-B113C587C705}"/>
+              </a:ext>
+            </a:extLst>
+          </p:cNvPr>
+          <p:cNvSpPr>
+            <a:spLocks noGrp="1"/>
+          </p:cNvSpPr>
+          <p:nvPr>
+            <p:ph type="title"/>
+          </p:nvPr>
         </p:nvSpPr>
-        <p:spPr>
-          <a:xfrm>
-            <a:off x="666750" y="476250"/>
-            <a:ext cx="11401425" cy="492443"/>
-          </a:xfrm>
-          <a:prstGeom prst="rect">
-            <a:avLst/>
-          </a:prstGeom>
-          <a:noFill/>
-          <a:ln>
-            <a:noFill/>
-          </a:ln>
-        </p:spPr>
+        <p:spPr/>
         <p:txBody>
-          <a:bodyPr spcFirstLastPara="1" wrap="square" lIns="0" tIns="0" rIns="0" bIns="0" anchor="t" anchorCtr="0">
-            <a:spAutoFit/>
+          <a:bodyPr>
+            <a:noAutofit/>
           </a:bodyPr>
           <a:lstStyle/>
           <a:p>
-            <a:pPr marL="0" marR="0" lvl="0" indent="0" algn="ctr" rtl="0">
-              <a:spcBef>
-                <a:spcPts val="0"/>
-              </a:spcBef>
-              <a:spcAft>
-                <a:spcPts val="0"/>
-              </a:spcAft>
-              <a:buNone/>
-            </a:pPr>
-            <a:r>
-              <a:rPr lang="en-US" sz="3200" b="1" i="0" u="none" strike="noStrike" cap="none" dirty="0">
+            <a:r>
+              <a:rPr lang="en-US" sz="3200" b="1" dirty="0">
                 <a:solidFill>
                   <a:srgbClr val="003366"/>
                 </a:solidFill>
@@ -9998,60 +9444,55 @@
                 <a:cs typeface="Montserrat"/>
                 <a:sym typeface="Montserrat"/>
               </a:rPr>
-              <a:t>GLOBAL BOZOR ANALIZI</a:t>
-            </a:r>
-            <a:endParaRPr sz="3200" dirty="0"/>
+              <a:t>IJROCHI XULOSA (EXECUTIVE SUMMARY)</a:t>
+            </a:r>
+            <a:endParaRPr lang="ru-RU" sz="3200" dirty="0"/>
           </a:p>
         </p:txBody>
       </p:sp>
       <p:sp>
         <p:nvSpPr>
-          <p:cNvPr id="120" name="Google Shape;120;p16"/>
-          <p:cNvSpPr txBox="1"/>
-          <p:nvPr/>
+          <p:cNvPr id="3" name="Текст 2">
+            <a:extLst>
+              <a:ext uri="{FF2B5EF4-FFF2-40B4-BE49-F238E27FC236}">
+                <a16:creationId xmlns:a16="http://schemas.microsoft.com/office/drawing/2014/main" id="{EF041492-2A69-862D-5B40-493977262BDD}"/>
+              </a:ext>
+            </a:extLst>
+          </p:cNvPr>
+          <p:cNvSpPr>
+            <a:spLocks noGrp="1"/>
+          </p:cNvSpPr>
+          <p:nvPr>
+            <p:ph type="body" idx="1"/>
+          </p:nvPr>
         </p:nvSpPr>
-        <p:spPr>
-          <a:xfrm>
-            <a:off x="676275" y="1985962"/>
-            <a:ext cx="10827467" cy="553998"/>
-          </a:xfrm>
-          <a:prstGeom prst="rect">
-            <a:avLst/>
-          </a:prstGeom>
-          <a:noFill/>
-          <a:ln>
-            <a:noFill/>
-          </a:ln>
-        </p:spPr>
+        <p:spPr/>
         <p:txBody>
-          <a:bodyPr spcFirstLastPara="1" wrap="square" lIns="0" tIns="0" rIns="0" bIns="0" anchor="t" anchorCtr="0">
-            <a:spAutoFit/>
+          <a:bodyPr>
+            <a:normAutofit/>
           </a:bodyPr>
           <a:lstStyle/>
           <a:p>
-            <a:pPr marL="0" marR="0" lvl="0" indent="0" algn="l" rtl="0">
-              <a:spcBef>
-                <a:spcPts val="0"/>
-              </a:spcBef>
-              <a:spcAft>
-                <a:spcPts val="0"/>
-              </a:spcAft>
+            <a:pPr marL="0" indent="0">
+              <a:spcBef>
+                <a:spcPts val="0"/>
+              </a:spcBef>
               <a:buNone/>
             </a:pPr>
             <a:r>
-              <a:rPr lang="en-US" sz="1800" b="0" i="0" u="none" strike="noStrike" cap="none" dirty="0" err="1">
-                <a:solidFill>
-                  <a:srgbClr val="334155"/>
-                </a:solidFill>
-                <a:latin typeface="Lato"/>
-                <a:ea typeface="Lato"/>
-                <a:cs typeface="Lato"/>
-                <a:sym typeface="Lato"/>
-              </a:rPr>
-              <a:t>Hamkorlik</a:t>
-            </a:r>
-            <a:r>
-              <a:rPr lang="en-US" sz="1800" b="0" i="0" u="none" strike="noStrike" cap="none" dirty="0">
+              <a:rPr lang="en-US" sz="2000" b="1" dirty="0" err="1">
+                <a:solidFill>
+                  <a:srgbClr val="334155"/>
+                </a:solidFill>
+                <a:latin typeface="Lato"/>
+                <a:ea typeface="Lato"/>
+                <a:cs typeface="Lato"/>
+                <a:sym typeface="Lato"/>
+              </a:rPr>
+              <a:t>Strategik</a:t>
+            </a:r>
+            <a:r>
+              <a:rPr lang="en-US" sz="2000" b="1" dirty="0">
                 <a:solidFill>
                   <a:srgbClr val="334155"/>
                 </a:solidFill>
@@ -10063,19 +9504,55 @@
               <a:t> </a:t>
             </a:r>
             <a:r>
-              <a:rPr lang="en-US" sz="1800" b="0" i="0" u="none" strike="noStrike" cap="none" dirty="0" err="1">
-                <a:solidFill>
-                  <a:srgbClr val="334155"/>
-                </a:solidFill>
-                <a:latin typeface="Lato"/>
-                <a:ea typeface="Lato"/>
-                <a:cs typeface="Lato"/>
-                <a:sym typeface="Lato"/>
-              </a:rPr>
-              <a:t>aloqalarini</a:t>
-            </a:r>
-            <a:r>
-              <a:rPr lang="en-US" sz="1800" b="0" i="0" u="none" strike="noStrike" cap="none" dirty="0">
+              <a:rPr lang="en-US" sz="2000" b="1" dirty="0" err="1">
+                <a:solidFill>
+                  <a:srgbClr val="334155"/>
+                </a:solidFill>
+                <a:latin typeface="Lato"/>
+                <a:ea typeface="Lato"/>
+                <a:cs typeface="Lato"/>
+                <a:sym typeface="Lato"/>
+              </a:rPr>
+              <a:t>ustuvorlik</a:t>
+            </a:r>
+            <a:r>
+              <a:rPr lang="en-US" sz="2000" b="1" dirty="0">
+                <a:solidFill>
+                  <a:srgbClr val="334155"/>
+                </a:solidFill>
+                <a:latin typeface="Lato"/>
+                <a:ea typeface="Lato"/>
+                <a:cs typeface="Lato"/>
+                <a:sym typeface="Lato"/>
+              </a:rPr>
+              <a:t>:</a:t>
+            </a:r>
+            <a:r>
+              <a:rPr lang="en-US" sz="2000" dirty="0">
+                <a:solidFill>
+                  <a:srgbClr val="334155"/>
+                </a:solidFill>
+                <a:latin typeface="Lato"/>
+                <a:ea typeface="Lato"/>
+                <a:cs typeface="Lato"/>
+                <a:sym typeface="Lato"/>
+              </a:rPr>
+              <a:t> 2025-yilda </a:t>
+            </a:r>
+            <a:r>
+              <a:rPr lang="en-US" sz="2000" dirty="0" err="1">
+                <a:solidFill>
+                  <a:srgbClr val="334155"/>
+                </a:solidFill>
+                <a:latin typeface="Lato"/>
+                <a:ea typeface="Lato"/>
+                <a:cs typeface="Lato"/>
+                <a:sym typeface="Lato"/>
+              </a:rPr>
+              <a:t>asosiy</a:t>
+            </a:r>
+            <a:r>
+              <a:rPr lang="en-US" sz="2000" dirty="0">
                 <a:solidFill>
                   <a:srgbClr val="334155"/>
                 </a:solidFill>
@@ -10087,19 +9564,43 @@
               <a:t> </a:t>
             </a:r>
             <a:r>
-              <a:rPr lang="en-US" sz="1800" b="0" i="0" u="none" strike="noStrike" cap="none" dirty="0" err="1">
-                <a:solidFill>
-                  <a:srgbClr val="334155"/>
-                </a:solidFill>
-                <a:latin typeface="Lato"/>
-                <a:ea typeface="Lato"/>
-                <a:cs typeface="Lato"/>
-                <a:sym typeface="Lato"/>
-              </a:rPr>
-              <a:t>mustahkamlash</a:t>
-            </a:r>
-            <a:r>
-              <a:rPr lang="en-US" sz="1800" b="0" i="0" u="none" strike="noStrike" cap="none" dirty="0">
+              <a:rPr lang="en-US" sz="2000" dirty="0" err="1">
+                <a:solidFill>
+                  <a:srgbClr val="334155"/>
+                </a:solidFill>
+                <a:latin typeface="Lato"/>
+                <a:ea typeface="Lato"/>
+                <a:cs typeface="Lato"/>
+                <a:sym typeface="Lato"/>
+              </a:rPr>
+              <a:t>e'tibor</a:t>
+            </a:r>
+            <a:r>
+              <a:rPr lang="en-US" sz="2000" dirty="0">
+                <a:solidFill>
+                  <a:srgbClr val="334155"/>
+                </a:solidFill>
+                <a:latin typeface="Lato"/>
+                <a:ea typeface="Lato"/>
+                <a:cs typeface="Lato"/>
+                <a:sym typeface="Lato"/>
+              </a:rPr>
+              <a:t> global </a:t>
+            </a:r>
+            <a:r>
+              <a:rPr lang="en-US" sz="2000" dirty="0" err="1">
+                <a:solidFill>
+                  <a:srgbClr val="334155"/>
+                </a:solidFill>
+                <a:latin typeface="Lato"/>
+                <a:ea typeface="Lato"/>
+                <a:cs typeface="Lato"/>
+                <a:sym typeface="Lato"/>
+              </a:rPr>
+              <a:t>ekspansiya</a:t>
+            </a:r>
+            <a:r>
+              <a:rPr lang="en-US" sz="2000" dirty="0">
                 <a:solidFill>
                   <a:srgbClr val="334155"/>
                 </a:solidFill>
@@ -10111,19 +9612,19 @@
               <a:t> </a:t>
             </a:r>
             <a:r>
-              <a:rPr lang="en-US" sz="1800" b="0" i="0" u="none" strike="noStrike" cap="none" dirty="0" err="1">
-                <a:solidFill>
-                  <a:srgbClr val="334155"/>
-                </a:solidFill>
-                <a:latin typeface="Lato"/>
-                <a:ea typeface="Lato"/>
-                <a:cs typeface="Lato"/>
-                <a:sym typeface="Lato"/>
-              </a:rPr>
-              <a:t>orqali</a:t>
-            </a:r>
-            <a:r>
-              <a:rPr lang="en-US" sz="1800" b="0" i="0" u="none" strike="noStrike" cap="none" dirty="0">
+              <a:rPr lang="en-US" sz="2000" dirty="0" err="1">
+                <a:solidFill>
+                  <a:srgbClr val="334155"/>
+                </a:solidFill>
+                <a:latin typeface="Lato"/>
+                <a:ea typeface="Lato"/>
+                <a:cs typeface="Lato"/>
+                <a:sym typeface="Lato"/>
+              </a:rPr>
+              <a:t>va</a:t>
+            </a:r>
+            <a:r>
+              <a:rPr lang="en-US" sz="2000" dirty="0">
                 <a:solidFill>
                   <a:srgbClr val="334155"/>
                 </a:solidFill>
@@ -10135,19 +9636,19 @@
               <a:t> </a:t>
             </a:r>
             <a:r>
-              <a:rPr lang="en-US" sz="1800" b="0" i="0" u="none" strike="noStrike" cap="none" dirty="0" err="1">
-                <a:solidFill>
-                  <a:srgbClr val="334155"/>
-                </a:solidFill>
-                <a:latin typeface="Lato"/>
-                <a:ea typeface="Lato"/>
-                <a:cs typeface="Lato"/>
-                <a:sym typeface="Lato"/>
-              </a:rPr>
-              <a:t>ta'minot</a:t>
-            </a:r>
-            <a:r>
-              <a:rPr lang="en-US" sz="1800" b="0" i="0" u="none" strike="noStrike" cap="none" dirty="0">
+              <a:rPr lang="en-US" sz="2000" dirty="0" err="1">
+                <a:solidFill>
+                  <a:srgbClr val="334155"/>
+                </a:solidFill>
+                <a:latin typeface="Lato"/>
+                <a:ea typeface="Lato"/>
+                <a:cs typeface="Lato"/>
+                <a:sym typeface="Lato"/>
+              </a:rPr>
+              <a:t>mijozlarga</a:t>
+            </a:r>
+            <a:r>
+              <a:rPr lang="en-US" sz="2000" dirty="0">
                 <a:solidFill>
                   <a:srgbClr val="334155"/>
                 </a:solidFill>
@@ -10159,19 +9660,19 @@
               <a:t> </a:t>
             </a:r>
             <a:r>
-              <a:rPr lang="en-US" sz="1800" b="0" i="0" u="none" strike="noStrike" cap="none" dirty="0" err="1">
-                <a:solidFill>
-                  <a:srgbClr val="334155"/>
-                </a:solidFill>
-                <a:latin typeface="Lato"/>
-                <a:ea typeface="Lato"/>
-                <a:cs typeface="Lato"/>
-                <a:sym typeface="Lato"/>
-              </a:rPr>
-              <a:t>zanjiri</a:t>
-            </a:r>
-            <a:r>
-              <a:rPr lang="en-US" sz="1800" b="0" i="0" u="none" strike="noStrike" cap="none" dirty="0">
+              <a:rPr lang="en-US" sz="2000" dirty="0" err="1">
+                <a:solidFill>
+                  <a:srgbClr val="334155"/>
+                </a:solidFill>
+                <a:latin typeface="Lato"/>
+                <a:ea typeface="Lato"/>
+                <a:cs typeface="Lato"/>
+                <a:sym typeface="Lato"/>
+              </a:rPr>
+              <a:t>yo'naltirilgan</a:t>
+            </a:r>
+            <a:r>
+              <a:rPr lang="en-US" sz="2000" dirty="0">
                 <a:solidFill>
                   <a:srgbClr val="334155"/>
                 </a:solidFill>
@@ -10183,153 +9684,72 @@
               <a:t> </a:t>
             </a:r>
             <a:r>
-              <a:rPr lang="en-US" sz="1800" b="0" i="0" u="none" strike="noStrike" cap="none" dirty="0" err="1">
-                <a:solidFill>
-                  <a:srgbClr val="334155"/>
-                </a:solidFill>
-                <a:latin typeface="Lato"/>
-                <a:ea typeface="Lato"/>
-                <a:cs typeface="Lato"/>
-                <a:sym typeface="Lato"/>
-              </a:rPr>
-              <a:t>barqarorligi</a:t>
-            </a:r>
-            <a:r>
-              <a:rPr lang="en-US" sz="1800" b="0" i="0" u="none" strike="noStrike" cap="none" dirty="0">
-                <a:solidFill>
-                  <a:srgbClr val="334155"/>
-                </a:solidFill>
-                <a:latin typeface="Lato"/>
-                <a:ea typeface="Lato"/>
-                <a:cs typeface="Lato"/>
-                <a:sym typeface="Lato"/>
-              </a:rPr>
-              <a:t> 98% ga </a:t>
-            </a:r>
+              <a:rPr lang="en-US" sz="2000" dirty="0" err="1">
+                <a:solidFill>
+                  <a:srgbClr val="334155"/>
+                </a:solidFill>
+                <a:latin typeface="Lato"/>
+                <a:ea typeface="Lato"/>
+                <a:cs typeface="Lato"/>
+                <a:sym typeface="Lato"/>
+              </a:rPr>
+              <a:t>innovatsiyalarga</a:t>
+            </a:r>
+            <a:r>
+              <a:rPr lang="en-US" sz="2000" dirty="0">
+                <a:solidFill>
+                  <a:srgbClr val="334155"/>
+                </a:solidFill>
+                <a:latin typeface="Lato"/>
+                <a:ea typeface="Lato"/>
+                <a:cs typeface="Lato"/>
+                <a:sym typeface="Lato"/>
+              </a:rPr>
+              <a:t> </a:t>
+            </a:r>
+            <a:r>
+              <a:rPr lang="en-US" sz="2000" dirty="0" err="1">
+                <a:solidFill>
+                  <a:srgbClr val="334155"/>
+                </a:solidFill>
+                <a:latin typeface="Lato"/>
+                <a:ea typeface="Lato"/>
+                <a:cs typeface="Lato"/>
+                <a:sym typeface="Lato"/>
+              </a:rPr>
+              <a:t>qaratiladi</a:t>
+            </a:r>
+            <a:r>
+              <a:rPr lang="en-US" sz="2000" dirty="0">
+                <a:solidFill>
+                  <a:srgbClr val="334155"/>
+                </a:solidFill>
+                <a:latin typeface="Lato"/>
+                <a:ea typeface="Lato"/>
+                <a:cs typeface="Lato"/>
+                <a:sym typeface="Lato"/>
+              </a:rPr>
+              <a:t>.</a:t>
+            </a:r>
+            <a:endParaRPr lang="en-US" sz="2000" dirty="0"/>
           </a:p>
           <a:p>
-            <a:pPr marL="0" marR="0" lvl="0" indent="0" algn="l" rtl="0">
-              <a:spcBef>
-                <a:spcPts val="0"/>
-              </a:spcBef>
-              <a:spcAft>
-                <a:spcPts val="0"/>
-              </a:spcAft>
+            <a:pPr marL="0" indent="0">
+              <a:spcBef>
+                <a:spcPts val="0"/>
+              </a:spcBef>
               <a:buNone/>
             </a:pPr>
-            <a:r>
-              <a:rPr lang="en-US" sz="1800" dirty="0" err="1">
-                <a:solidFill>
-                  <a:srgbClr val="334155"/>
-                </a:solidFill>
-                <a:latin typeface="Lato"/>
-                <a:ea typeface="Lato"/>
-                <a:cs typeface="Lato"/>
-                <a:sym typeface="Lato"/>
-              </a:rPr>
-              <a:t>Jfhalsk</a:t>
-            </a:r>
-            <a:r>
-              <a:rPr lang="en-US" sz="1800" dirty="0">
-                <a:solidFill>
-                  <a:srgbClr val="334155"/>
-                </a:solidFill>
-                <a:latin typeface="Lato"/>
-                <a:ea typeface="Lato"/>
-                <a:cs typeface="Lato"/>
-                <a:sym typeface="Lato"/>
-              </a:rPr>
-              <a:t> </a:t>
-            </a:r>
-            <a:r>
-              <a:rPr lang="en-US" sz="1800" dirty="0" err="1">
-                <a:solidFill>
-                  <a:srgbClr val="334155"/>
-                </a:solidFill>
-                <a:latin typeface="Lato"/>
-                <a:ea typeface="Lato"/>
-                <a:cs typeface="Lato"/>
-                <a:sym typeface="Lato"/>
-              </a:rPr>
-              <a:t>asjdfhakjf</a:t>
-            </a:r>
-            <a:r>
-              <a:rPr lang="en-US" sz="1800" dirty="0">
-                <a:solidFill>
-                  <a:srgbClr val="334155"/>
-                </a:solidFill>
-                <a:latin typeface="Lato"/>
-                <a:ea typeface="Lato"/>
-                <a:cs typeface="Lato"/>
-                <a:sym typeface="Lato"/>
-              </a:rPr>
-              <a:t> </a:t>
-            </a:r>
-            <a:r>
-              <a:rPr lang="en-US" sz="1800" dirty="0" err="1">
-                <a:solidFill>
-                  <a:srgbClr val="334155"/>
-                </a:solidFill>
-                <a:latin typeface="Lato"/>
-                <a:ea typeface="Lato"/>
-                <a:cs typeface="Lato"/>
-                <a:sym typeface="Lato"/>
-              </a:rPr>
-              <a:t>askjfhasdkfjasmhfansd</a:t>
-            </a:r>
-            <a:r>
-              <a:rPr lang="en-US" sz="1800" dirty="0">
-                <a:solidFill>
-                  <a:srgbClr val="334155"/>
-                </a:solidFill>
-                <a:latin typeface="Lato"/>
-                <a:ea typeface="Lato"/>
-                <a:cs typeface="Lato"/>
-                <a:sym typeface="Lato"/>
-              </a:rPr>
-              <a:t> </a:t>
-            </a:r>
-            <a:r>
-              <a:rPr lang="en-US" sz="1800" dirty="0" err="1">
-                <a:solidFill>
-                  <a:srgbClr val="334155"/>
-                </a:solidFill>
-                <a:latin typeface="Lato"/>
-                <a:ea typeface="Lato"/>
-                <a:cs typeface="Lato"/>
-                <a:sym typeface="Lato"/>
-              </a:rPr>
-              <a:t>fkjadshlk</a:t>
-            </a:r>
-            <a:r>
-              <a:rPr lang="en-US" sz="1800" b="0" i="0" u="none" strike="noStrike" cap="none" dirty="0" err="1">
-                <a:solidFill>
-                  <a:srgbClr val="334155"/>
-                </a:solidFill>
-                <a:latin typeface="Lato"/>
-                <a:ea typeface="Lato"/>
-                <a:cs typeface="Lato"/>
-                <a:sym typeface="Lato"/>
-              </a:rPr>
-              <a:t>yetkazildi</a:t>
-            </a:r>
-            <a:r>
-              <a:rPr lang="en-US" sz="1800" b="0" i="0" u="none" strike="noStrike" cap="none" dirty="0">
-                <a:solidFill>
-                  <a:srgbClr val="334155"/>
-                </a:solidFill>
-                <a:latin typeface="Lato"/>
-                <a:ea typeface="Lato"/>
-                <a:cs typeface="Lato"/>
-                <a:sym typeface="Lato"/>
-              </a:rPr>
-              <a:t>.</a:t>
-            </a:r>
-            <a:endParaRPr sz="1800" dirty="0"/>
+            <a:endParaRPr lang="ru-RU" sz="2000" dirty="0"/>
           </a:p>
         </p:txBody>
       </p:sp>
     </p:spTree>
+    <p:extLst>
+      <p:ext uri="{BB962C8B-B14F-4D97-AF65-F5344CB8AC3E}">
+        <p14:creationId xmlns:p14="http://schemas.microsoft.com/office/powerpoint/2010/main" val="668529262"/>
+      </p:ext>
+    </p:extLst>
   </p:cSld>
   <p:clrMapOvr>
     <a:masterClrMapping/>
@@ -11244,6 +10664,18 @@
               <a:buNone/>
             </a:pPr>
             <a:r>
+              <a:rPr lang="en-US" sz="1800" b="1" i="0" u="none" strike="noStrike" cap="none" dirty="0" err="1">
+                <a:solidFill>
+                  <a:srgbClr val="003366"/>
+                </a:solidFill>
+                <a:latin typeface="Lato"/>
+                <a:ea typeface="Lato"/>
+                <a:cs typeface="Lato"/>
+                <a:sym typeface="Lato"/>
+              </a:rPr>
+              <a:t>Sotuv</a:t>
+            </a:r>
+            <a:r>
               <a:rPr lang="en-US" sz="1800" b="1" i="0" u="none" strike="noStrike" cap="none" dirty="0">
                 <a:solidFill>
                   <a:srgbClr val="003366"/>
@@ -11253,7 +10685,7 @@
                 <a:cs typeface="Lato"/>
                 <a:sym typeface="Lato"/>
               </a:rPr>
-              <a:t>Sotuv </a:t>
+              <a:t> </a:t>
             </a:r>
             <a:r>
               <a:rPr lang="en-US" sz="1800" b="1" i="0" u="none" strike="noStrike" cap="none" dirty="0" err="1">
@@ -11265,7 +10697,31 @@
                 <a:cs typeface="Lato"/>
                 <a:sym typeface="Lato"/>
               </a:rPr>
-              <a:t>hajmi</a:t>
+              <a:t>hajjkhfgk</a:t>
+            </a:r>
+            <a:r>
+              <a:rPr lang="en-US" sz="1800" b="1" i="0" u="none" strike="noStrike" cap="none" dirty="0">
+                <a:solidFill>
+                  <a:srgbClr val="003366"/>
+                </a:solidFill>
+                <a:latin typeface="Lato"/>
+                <a:ea typeface="Lato"/>
+                <a:cs typeface="Lato"/>
+                <a:sym typeface="Lato"/>
+              </a:rPr>
+              <a:t> </a:t>
+            </a:r>
+            <a:r>
+              <a:rPr lang="en-US" sz="1800" b="1" i="0" u="none" strike="noStrike" cap="none" dirty="0" err="1">
+                <a:solidFill>
+                  <a:srgbClr val="003366"/>
+                </a:solidFill>
+                <a:latin typeface="Lato"/>
+                <a:ea typeface="Lato"/>
+                <a:cs typeface="Lato"/>
+                <a:sym typeface="Lato"/>
+              </a:rPr>
+              <a:t>jhgbmi</a:t>
             </a:r>
             <a:endParaRPr sz="1800" dirty="0"/>
           </a:p>
@@ -11327,7 +10783,79 @@
                 <a:cs typeface="Lato"/>
                 <a:sym typeface="Lato"/>
               </a:rPr>
-              <a:t>foyda</a:t>
+              <a:t>fo</a:t>
+            </a:r>
+            <a:r>
+              <a:rPr lang="en-US" sz="1800" b="1" i="0" u="none" strike="noStrike" cap="none" dirty="0">
+                <a:solidFill>
+                  <a:srgbClr val="003366"/>
+                </a:solidFill>
+                <a:latin typeface="Lato"/>
+                <a:ea typeface="Lato"/>
+                <a:cs typeface="Lato"/>
+                <a:sym typeface="Lato"/>
+              </a:rPr>
+              <a:t> </a:t>
+            </a:r>
+            <a:r>
+              <a:rPr lang="en-US" sz="1800" b="1" i="0" u="none" strike="noStrike" cap="none" dirty="0" err="1">
+                <a:solidFill>
+                  <a:srgbClr val="003366"/>
+                </a:solidFill>
+                <a:latin typeface="Lato"/>
+                <a:ea typeface="Lato"/>
+                <a:cs typeface="Lato"/>
+                <a:sym typeface="Lato"/>
+              </a:rPr>
+              <a:t>jhgkujhhfgujhgukjj</a:t>
+            </a:r>
+            <a:r>
+              <a:rPr lang="en-US" sz="1800" b="1" i="0" u="none" strike="noStrike" cap="none" dirty="0">
+                <a:solidFill>
+                  <a:srgbClr val="003366"/>
+                </a:solidFill>
+                <a:latin typeface="Lato"/>
+                <a:ea typeface="Lato"/>
+                <a:cs typeface="Lato"/>
+                <a:sym typeface="Lato"/>
+              </a:rPr>
+              <a:t> </a:t>
+            </a:r>
+            <a:r>
+              <a:rPr lang="en-US" sz="1800" b="1" i="0" u="none" strike="noStrike" cap="none" dirty="0" err="1">
+                <a:solidFill>
+                  <a:srgbClr val="003366"/>
+                </a:solidFill>
+                <a:latin typeface="Lato"/>
+                <a:ea typeface="Lato"/>
+                <a:cs typeface="Lato"/>
+                <a:sym typeface="Lato"/>
+              </a:rPr>
+              <a:t>lh</a:t>
+            </a:r>
+            <a:r>
+              <a:rPr lang="en-US" sz="1800" b="1" i="0" u="none" strike="noStrike" cap="none" dirty="0">
+                <a:solidFill>
+                  <a:srgbClr val="003366"/>
+                </a:solidFill>
+                <a:latin typeface="Lato"/>
+                <a:ea typeface="Lato"/>
+                <a:cs typeface="Lato"/>
+                <a:sym typeface="Lato"/>
+              </a:rPr>
+              <a:t> </a:t>
+            </a:r>
+            <a:r>
+              <a:rPr lang="en-US" sz="1800" b="1" i="0" u="none" strike="noStrike" cap="none" dirty="0" err="1">
+                <a:solidFill>
+                  <a:srgbClr val="003366"/>
+                </a:solidFill>
+                <a:latin typeface="Lato"/>
+                <a:ea typeface="Lato"/>
+                <a:cs typeface="Lato"/>
+                <a:sym typeface="Lato"/>
+              </a:rPr>
+              <a:t>gukjyda</a:t>
             </a:r>
             <a:endParaRPr sz="2000" dirty="0"/>
           </a:p>
@@ -11456,36 +10984,325 @@
           </a:bodyPr>
           <a:lstStyle/>
           <a:p>
-            <a:pPr marL="114300" indent="0">
+            <a:pPr marL="0" lvl="0" indent="0">
+              <a:spcBef>
+                <a:spcPts val="0"/>
+              </a:spcBef>
               <a:buNone/>
             </a:pPr>
             <a:r>
+              <a:rPr lang="en-US" sz="1800" b="1" dirty="0">
+                <a:solidFill>
+                  <a:srgbClr val="334155"/>
+                </a:solidFill>
+                <a:latin typeface="Lato"/>
+                <a:ea typeface="Lato"/>
+                <a:cs typeface="Lato"/>
+                <a:sym typeface="Lato"/>
+              </a:rPr>
+              <a:t>Bozordagi </a:t>
+            </a:r>
+            <a:r>
+              <a:rPr lang="en-US" sz="1800" b="1" dirty="0" err="1">
+                <a:solidFill>
+                  <a:srgbClr val="334155"/>
+                </a:solidFill>
+                <a:latin typeface="Lato"/>
+                <a:ea typeface="Lato"/>
+                <a:cs typeface="Lato"/>
+                <a:sym typeface="Lato"/>
+              </a:rPr>
+              <a:t>yetakchilik</a:t>
+            </a:r>
+            <a:r>
+              <a:rPr lang="en-US" sz="1800" b="1" dirty="0">
+                <a:solidFill>
+                  <a:srgbClr val="334155"/>
+                </a:solidFill>
+                <a:latin typeface="Lato"/>
+                <a:ea typeface="Lato"/>
+                <a:cs typeface="Lato"/>
+                <a:sym typeface="Lato"/>
+              </a:rPr>
+              <a:t>:</a:t>
+            </a:r>
+            <a:r>
               <a:rPr lang="en-US" sz="1800" dirty="0">
                 <a:solidFill>
                   <a:srgbClr val="334155"/>
                 </a:solidFill>
-                <a:latin typeface="Lato" panose="020F0502020204030203" pitchFamily="34" charset="0"/>
-                <a:ea typeface="Lato" panose="020F0502020204030203" pitchFamily="34" charset="0"/>
-                <a:cs typeface="Lato" panose="020F0502020204030203" pitchFamily="34" charset="0"/>
-                <a:sym typeface="Lato"/>
-              </a:rPr>
-              <a:t>https://static.vecteezy.com/system/resources/thumbnails/076/883/043/small/handshake-meeting-and-business-women-in-office-for-partnership-financial-advisor-and-agreement-corporate-professional-and-people-shaking-hands-for-investment-deal-negotiation-and-teamwork-photo.jpg</a:t>
-            </a:r>
-            <a:endParaRPr lang="en-US" sz="1800" dirty="0">
-              <a:latin typeface="Lato" panose="020F0502020204030203" pitchFamily="34" charset="0"/>
-              <a:ea typeface="Lato" panose="020F0502020204030203" pitchFamily="34" charset="0"/>
-              <a:cs typeface="Lato" panose="020F0502020204030203" pitchFamily="34" charset="0"/>
-            </a:endParaRPr>
-          </a:p>
-          <a:p>
-            <a:pPr marL="114300" indent="0">
-              <a:buNone/>
-            </a:pPr>
-            <a:endParaRPr lang="ru-RU" sz="1800" dirty="0">
-              <a:latin typeface="Lato" panose="020F0502020204030203" pitchFamily="34" charset="0"/>
-              <a:ea typeface="Lato" panose="020F0502020204030203" pitchFamily="34" charset="0"/>
-              <a:cs typeface="Lato" panose="020F0502020204030203" pitchFamily="34" charset="0"/>
-            </a:endParaRPr>
+                <a:latin typeface="Lato"/>
+                <a:ea typeface="Lato"/>
+                <a:cs typeface="Lato"/>
+                <a:sym typeface="Lato"/>
+              </a:rPr>
+              <a:t> </a:t>
+            </a:r>
+            <a:r>
+              <a:rPr lang="en-US" sz="1800" dirty="0" err="1">
+                <a:solidFill>
+                  <a:srgbClr val="334155"/>
+                </a:solidFill>
+                <a:latin typeface="Lato"/>
+                <a:ea typeface="Lato"/>
+                <a:cs typeface="Lato"/>
+                <a:sym typeface="Lato"/>
+              </a:rPr>
+              <a:t>Joriy</a:t>
+            </a:r>
+            <a:r>
+              <a:rPr lang="en-US" sz="1800" dirty="0">
+                <a:solidFill>
+                  <a:srgbClr val="334155"/>
+                </a:solidFill>
+                <a:latin typeface="Lato"/>
+                <a:ea typeface="Lato"/>
+                <a:cs typeface="Lato"/>
+                <a:sym typeface="Lato"/>
+              </a:rPr>
+              <a:t> </a:t>
+            </a:r>
+            <a:r>
+              <a:rPr lang="en-US" sz="1800" dirty="0" err="1">
+                <a:solidFill>
+                  <a:srgbClr val="334155"/>
+                </a:solidFill>
+                <a:latin typeface="Lato"/>
+                <a:ea typeface="Lato"/>
+                <a:cs typeface="Lato"/>
+                <a:sym typeface="Lato"/>
+              </a:rPr>
+              <a:t>yilda</a:t>
+            </a:r>
+            <a:r>
+              <a:rPr lang="en-US" sz="1800" dirty="0">
+                <a:solidFill>
+                  <a:srgbClr val="334155"/>
+                </a:solidFill>
+                <a:latin typeface="Lato"/>
+                <a:ea typeface="Lato"/>
+                <a:cs typeface="Lato"/>
+                <a:sym typeface="Lato"/>
+              </a:rPr>
+              <a:t> </a:t>
+            </a:r>
+            <a:r>
+              <a:rPr lang="en-US" sz="1800" dirty="0" err="1">
+                <a:solidFill>
+                  <a:srgbClr val="334155"/>
+                </a:solidFill>
+                <a:latin typeface="Lato"/>
+                <a:ea typeface="Lato"/>
+                <a:cs typeface="Lato"/>
+                <a:sym typeface="Lato"/>
+              </a:rPr>
+              <a:t>kompaniyamiz</a:t>
+            </a:r>
+            <a:r>
+              <a:rPr lang="en-US" sz="1800" dirty="0">
+                <a:solidFill>
+                  <a:srgbClr val="334155"/>
+                </a:solidFill>
+                <a:latin typeface="Lato"/>
+                <a:ea typeface="Lato"/>
+                <a:cs typeface="Lato"/>
+                <a:sym typeface="Lato"/>
+              </a:rPr>
+              <a:t> </a:t>
+            </a:r>
+            <a:r>
+              <a:rPr lang="en-US" sz="1800" dirty="0" err="1">
+                <a:solidFill>
+                  <a:srgbClr val="334155"/>
+                </a:solidFill>
+                <a:latin typeface="Lato"/>
+                <a:ea typeface="Lato"/>
+                <a:cs typeface="Lato"/>
+                <a:sym typeface="Lato"/>
+              </a:rPr>
+              <a:t>asosiy</a:t>
+            </a:r>
+            <a:r>
+              <a:rPr lang="en-US" sz="1800" dirty="0">
+                <a:solidFill>
+                  <a:srgbClr val="334155"/>
+                </a:solidFill>
+                <a:latin typeface="Lato"/>
+                <a:ea typeface="Lato"/>
+                <a:cs typeface="Lato"/>
+                <a:sym typeface="Lato"/>
+              </a:rPr>
+              <a:t> </a:t>
+            </a:r>
+            <a:r>
+              <a:rPr lang="en-US" sz="1800" dirty="0" err="1">
+                <a:solidFill>
+                  <a:srgbClr val="334155"/>
+                </a:solidFill>
+                <a:latin typeface="Lato"/>
+                <a:ea typeface="Lato"/>
+                <a:cs typeface="Lato"/>
+                <a:sym typeface="Lato"/>
+              </a:rPr>
+              <a:t>segmentlarda</a:t>
+            </a:r>
+            <a:r>
+              <a:rPr lang="en-US" sz="1800" dirty="0">
+                <a:solidFill>
+                  <a:srgbClr val="334155"/>
+                </a:solidFill>
+                <a:latin typeface="Lato"/>
+                <a:ea typeface="Lato"/>
+                <a:cs typeface="Lato"/>
+                <a:sym typeface="Lato"/>
+              </a:rPr>
+              <a:t> 12% </a:t>
+            </a:r>
+            <a:r>
+              <a:rPr lang="en-US" sz="1800" dirty="0" err="1">
+                <a:solidFill>
+                  <a:srgbClr val="334155"/>
+                </a:solidFill>
+                <a:latin typeface="Lato"/>
+                <a:ea typeface="Lato"/>
+                <a:cs typeface="Lato"/>
+                <a:sym typeface="Lato"/>
+              </a:rPr>
+              <a:t>o'sishga</a:t>
+            </a:r>
+            <a:r>
+              <a:rPr lang="en-US" sz="1800" dirty="0">
+                <a:solidFill>
+                  <a:srgbClr val="334155"/>
+                </a:solidFill>
+                <a:latin typeface="Lato"/>
+                <a:ea typeface="Lato"/>
+                <a:cs typeface="Lato"/>
+                <a:sym typeface="Lato"/>
+              </a:rPr>
+              <a:t> </a:t>
+            </a:r>
+            <a:r>
+              <a:rPr lang="en-US" sz="1800" dirty="0" err="1">
+                <a:solidFill>
+                  <a:srgbClr val="334155"/>
+                </a:solidFill>
+                <a:latin typeface="Lato"/>
+                <a:ea typeface="Lato"/>
+                <a:cs typeface="Lato"/>
+                <a:sym typeface="Lato"/>
+              </a:rPr>
+              <a:t>erishdi</a:t>
+            </a:r>
+            <a:r>
+              <a:rPr lang="en-US" sz="1800" dirty="0">
+                <a:solidFill>
+                  <a:srgbClr val="334155"/>
+                </a:solidFill>
+                <a:latin typeface="Lato"/>
+                <a:ea typeface="Lato"/>
+                <a:cs typeface="Lato"/>
+                <a:sym typeface="Lato"/>
+              </a:rPr>
+              <a:t> </a:t>
+            </a:r>
+            <a:r>
+              <a:rPr lang="en-US" sz="1800" dirty="0" err="1">
+                <a:solidFill>
+                  <a:srgbClr val="334155"/>
+                </a:solidFill>
+                <a:latin typeface="Lato"/>
+                <a:ea typeface="Lato"/>
+                <a:cs typeface="Lato"/>
+                <a:sym typeface="Lato"/>
+              </a:rPr>
+              <a:t>va</a:t>
+            </a:r>
+            <a:r>
+              <a:rPr lang="en-US" sz="1800" dirty="0">
+                <a:solidFill>
+                  <a:srgbClr val="334155"/>
+                </a:solidFill>
+                <a:latin typeface="Lato"/>
+                <a:ea typeface="Lato"/>
+                <a:cs typeface="Lato"/>
+                <a:sym typeface="Lato"/>
+              </a:rPr>
+              <a:t> </a:t>
+            </a:r>
+            <a:r>
+              <a:rPr lang="en-US" sz="1800" dirty="0" err="1">
+                <a:solidFill>
+                  <a:srgbClr val="334155"/>
+                </a:solidFill>
+                <a:latin typeface="Lato"/>
+                <a:ea typeface="Lato"/>
+                <a:cs typeface="Lato"/>
+                <a:sym typeface="Lato"/>
+              </a:rPr>
+              <a:t>bozor</a:t>
+            </a:r>
+            <a:r>
+              <a:rPr lang="en-US" sz="1800" dirty="0">
+                <a:solidFill>
+                  <a:srgbClr val="334155"/>
+                </a:solidFill>
+                <a:latin typeface="Lato"/>
+                <a:ea typeface="Lato"/>
+                <a:cs typeface="Lato"/>
+                <a:sym typeface="Lato"/>
+              </a:rPr>
+              <a:t> </a:t>
+            </a:r>
+            <a:r>
+              <a:rPr lang="en-US" sz="1800" dirty="0" err="1">
+                <a:solidFill>
+                  <a:srgbClr val="334155"/>
+                </a:solidFill>
+                <a:latin typeface="Lato"/>
+                <a:ea typeface="Lato"/>
+                <a:cs typeface="Lato"/>
+                <a:sym typeface="Lato"/>
+              </a:rPr>
+              <a:t>ulushini</a:t>
+            </a:r>
+            <a:r>
+              <a:rPr lang="en-US" sz="1800" dirty="0">
+                <a:solidFill>
+                  <a:srgbClr val="334155"/>
+                </a:solidFill>
+                <a:latin typeface="Lato"/>
+                <a:ea typeface="Lato"/>
+                <a:cs typeface="Lato"/>
+                <a:sym typeface="Lato"/>
+              </a:rPr>
+              <a:t> </a:t>
+            </a:r>
+            <a:r>
+              <a:rPr lang="en-US" sz="1800" dirty="0" err="1">
+                <a:solidFill>
+                  <a:srgbClr val="334155"/>
+                </a:solidFill>
+                <a:latin typeface="Lato"/>
+                <a:ea typeface="Lato"/>
+                <a:cs typeface="Lato"/>
+                <a:sym typeface="Lato"/>
+              </a:rPr>
+              <a:t>mustahkamladi</a:t>
+            </a:r>
+            <a:r>
+              <a:rPr lang="en-US" sz="1800" dirty="0">
+                <a:solidFill>
+                  <a:srgbClr val="334155"/>
+                </a:solidFill>
+                <a:latin typeface="Lato"/>
+                <a:ea typeface="Lato"/>
+                <a:cs typeface="Lato"/>
+                <a:sym typeface="Lato"/>
+              </a:rPr>
+              <a:t>.</a:t>
+            </a:r>
+            <a:endParaRPr lang="en-US" sz="1600" dirty="0"/>
           </a:p>
         </p:txBody>
       </p:sp>
@@ -11594,7 +11411,7 @@
               <a:buNone/>
             </a:pPr>
             <a:r>
-              <a:rPr lang="en-US" sz="4000" b="1" i="0" u="none" strike="noStrike" cap="none" dirty="0" err="1">
+              <a:rPr lang="en-US" sz="4000" b="1" dirty="0">
                 <a:solidFill>
                   <a:srgbClr val="003366"/>
                 </a:solidFill>
@@ -11603,7 +11420,19 @@
                 <a:cs typeface="Montserrat"/>
                 <a:sym typeface="Montserrat"/>
               </a:rPr>
-              <a:t>Uchun</a:t>
+              <a:t>u</a:t>
+            </a:r>
+            <a:r>
+              <a:rPr lang="en-US" sz="4000" b="1" i="0" u="none" strike="noStrike" cap="none">
+                <a:solidFill>
+                  <a:srgbClr val="003366"/>
+                </a:solidFill>
+                <a:latin typeface="Montserrat"/>
+                <a:ea typeface="Montserrat"/>
+                <a:cs typeface="Montserrat"/>
+                <a:sym typeface="Montserrat"/>
+              </a:rPr>
+              <a:t>chun</a:t>
             </a:r>
             <a:endParaRPr lang="en-US" sz="4000" b="1" dirty="0">
               <a:solidFill>

</xml_diff>